<commit_message>
Refactor LaTeX document for improved formatting and clarity
- Enhanced page break control to prevent widows and orphans, ensuring better visual presentation.
- Adjusted section spacing and added \Needspace commands to maintain content cohesion.
- Updated bibliography handling to allow for better formatting and reduced whitespace.
- Corrected dataset references in results and conclusions to reflect accurate observation counts.
- Improved clarity in the description of clustering results and accuracy metrics.
- Added space reservation in the appendix to prevent orphaned titles.
- Minor adjustments to the table of contents for consistency in section numbering.
</commit_message>
<xml_diff>
--- a/presentacion.pptx
+++ b/presentacion.pptx
@@ -5167,6 +5167,38 @@
                 </a:solidFill>
                 <a:latin typeface="Calibri"/>
               </a:rPr>
+              <a:t>• Tras mapear cluster → especie por mayoría: exactitud 96.8 % (331/342).</a:t>
+            </a:r>
+          </a:p>
+          <a:p>
+            <a:pPr algn="l">
+              <a:spcAft>
+                <a:spcPts val="600"/>
+              </a:spcAft>
+            </a:pPr>
+            <a:r>
+              <a:rPr sz="1500">
+                <a:solidFill>
+                  <a:srgbClr val="222222"/>
+                </a:solidFill>
+                <a:latin typeface="Calibri"/>
+              </a:rPr>
+              <a:t>• Mapeo: Cluster 0 → Adelie, Cluster 1 → Gentoo, Cluster 2 → Chinstrap.</a:t>
+            </a:r>
+          </a:p>
+          <a:p>
+            <a:pPr algn="l">
+              <a:spcAft>
+                <a:spcPts val="600"/>
+              </a:spcAft>
+            </a:pPr>
+            <a:r>
+              <a:rPr sz="1500">
+                <a:solidFill>
+                  <a:srgbClr val="222222"/>
+                </a:solidFill>
+                <a:latin typeface="Calibri"/>
+              </a:rPr>
               <a:t>• DBSCAN tiene mejor compacidad interna pero fusiona Adelie/Chinstrap.</a:t>
             </a:r>
           </a:p>
@@ -5467,7 +5499,7 @@
                 </a:solidFill>
                 <a:latin typeface="Calibri"/>
               </a:rPr>
-              <a:t>• Solo 4 variables numéricas y dataset pequeño (~333 filas tras limpieza).</a:t>
+              <a:t>• Solo 4 variables numéricas y dataset pequeño (342 filas tras limpieza).</a:t>
             </a:r>
           </a:p>
           <a:p>

</xml_diff>

<commit_message>
Update presentation file with latest content revisions
</commit_message>
<xml_diff>
--- a/presentacion.pptx
+++ b/presentacion.pptx
@@ -5,14 +5,14 @@
     <p:sldMasterId id="2147483648" r:id="rId1"/>
   </p:sldMasterIdLst>
   <p:sldIdLst>
-    <p:sldId id="256" r:id="rId7"/>
-    <p:sldId id="257" r:id="rId8"/>
-    <p:sldId id="258" r:id="rId9"/>
-    <p:sldId id="259" r:id="rId10"/>
-    <p:sldId id="260" r:id="rId11"/>
-    <p:sldId id="261" r:id="rId12"/>
+    <p:sldId id="256" r:id="rId2"/>
+    <p:sldId id="257" r:id="rId3"/>
+    <p:sldId id="258" r:id="rId4"/>
+    <p:sldId id="259" r:id="rId5"/>
+    <p:sldId id="260" r:id="rId6"/>
+    <p:sldId id="261" r:id="rId7"/>
   </p:sldIdLst>
-  <p:sldSz cx="12191695" cy="6858000" type="screen4x3"/>
+  <p:sldSz cx="12192000" cy="6858000"/>
   <p:notesSz cx="6858000" cy="9144000"/>
   <p:defaultTextStyle>
     <a:defPPr>
@@ -109,6 +109,22 @@
       </a:defRPr>
     </a:lvl9pPr>
   </p:defaultTextStyle>
+  <p:extLst>
+    <p:ext uri="{EFAFB233-063F-42B5-8137-9DF3F51BA10A}">
+      <p15:sldGuideLst xmlns:p15="http://schemas.microsoft.com/office/powerpoint/2012/main">
+        <p15:guide id="1" orient="horz" pos="2160">
+          <p15:clr>
+            <a:srgbClr val="A4A3A4"/>
+          </p15:clr>
+        </p15:guide>
+        <p15:guide id="2" pos="2880">
+          <p15:clr>
+            <a:srgbClr val="A4A3A4"/>
+          </p15:clr>
+        </p15:guide>
+      </p15:sldGuideLst>
+    </p:ext>
+  </p:extLst>
 </p:presentation>
 </file>
 
@@ -150,10 +166,9 @@
           <a:lstStyle/>
           <a:p>
             <a:r>
-              <a:rPr lang="en-US" smtClean="0"/>
+              <a:rPr lang="en-US"/>
               <a:t>Click to edit Master title style</a:t>
             </a:r>
-            <a:endParaRPr lang="en-US"/>
           </a:p>
         </p:txBody>
       </p:sp>
@@ -269,10 +284,9 @@
           </a:lstStyle>
           <a:p>
             <a:r>
-              <a:rPr lang="en-US" smtClean="0"/>
+              <a:rPr lang="en-US"/>
               <a:t>Click to edit Master subtitle style</a:t>
             </a:r>
-            <a:endParaRPr lang="en-US"/>
           </a:p>
         </p:txBody>
       </p:sp>
@@ -293,7 +307,7 @@
           <a:p>
             <a:fld id="{5BCAD085-E8A6-8845-BD4E-CB4CCA059FC4}" type="datetimeFigureOut">
               <a:rPr lang="en-US" smtClean="0"/>
-              <a:t>1/27/13</a:t>
+              <a:t>5/28/2026</a:t>
             </a:fld>
             <a:endParaRPr lang="en-US"/>
           </a:p>
@@ -387,10 +401,9 @@
           <a:lstStyle/>
           <a:p>
             <a:r>
-              <a:rPr lang="en-US" smtClean="0"/>
+              <a:rPr lang="en-US"/>
               <a:t>Click to edit Master title style</a:t>
             </a:r>
-            <a:endParaRPr lang="en-US"/>
           </a:p>
         </p:txBody>
       </p:sp>
@@ -411,38 +424,37 @@
           <a:p>
             <a:pPr lvl="0"/>
             <a:r>
-              <a:rPr lang="en-US" smtClean="0"/>
+              <a:rPr lang="en-US"/>
               <a:t>Click to edit Master text styles</a:t>
             </a:r>
           </a:p>
           <a:p>
             <a:pPr lvl="1"/>
             <a:r>
-              <a:rPr lang="en-US" smtClean="0"/>
+              <a:rPr lang="en-US"/>
               <a:t>Second level</a:t>
             </a:r>
           </a:p>
           <a:p>
             <a:pPr lvl="2"/>
             <a:r>
-              <a:rPr lang="en-US" smtClean="0"/>
+              <a:rPr lang="en-US"/>
               <a:t>Third level</a:t>
             </a:r>
           </a:p>
           <a:p>
             <a:pPr lvl="3"/>
             <a:r>
-              <a:rPr lang="en-US" smtClean="0"/>
+              <a:rPr lang="en-US"/>
               <a:t>Fourth level</a:t>
             </a:r>
           </a:p>
           <a:p>
             <a:pPr lvl="4"/>
             <a:r>
-              <a:rPr lang="en-US" smtClean="0"/>
+              <a:rPr lang="en-US"/>
               <a:t>Fifth level</a:t>
             </a:r>
-            <a:endParaRPr lang="en-US"/>
           </a:p>
         </p:txBody>
       </p:sp>
@@ -463,7 +475,7 @@
           <a:p>
             <a:fld id="{5BCAD085-E8A6-8845-BD4E-CB4CCA059FC4}" type="datetimeFigureOut">
               <a:rPr lang="en-US" smtClean="0"/>
-              <a:t>1/27/13</a:t>
+              <a:t>5/28/2026</a:t>
             </a:fld>
             <a:endParaRPr lang="en-US"/>
           </a:p>
@@ -562,10 +574,9 @@
           <a:lstStyle/>
           <a:p>
             <a:r>
-              <a:rPr lang="en-US" smtClean="0"/>
+              <a:rPr lang="en-US"/>
               <a:t>Click to edit Master title style</a:t>
             </a:r>
-            <a:endParaRPr lang="en-US"/>
           </a:p>
         </p:txBody>
       </p:sp>
@@ -591,38 +602,37 @@
           <a:p>
             <a:pPr lvl="0"/>
             <a:r>
-              <a:rPr lang="en-US" smtClean="0"/>
+              <a:rPr lang="en-US"/>
               <a:t>Click to edit Master text styles</a:t>
             </a:r>
           </a:p>
           <a:p>
             <a:pPr lvl="1"/>
             <a:r>
-              <a:rPr lang="en-US" smtClean="0"/>
+              <a:rPr lang="en-US"/>
               <a:t>Second level</a:t>
             </a:r>
           </a:p>
           <a:p>
             <a:pPr lvl="2"/>
             <a:r>
-              <a:rPr lang="en-US" smtClean="0"/>
+              <a:rPr lang="en-US"/>
               <a:t>Third level</a:t>
             </a:r>
           </a:p>
           <a:p>
             <a:pPr lvl="3"/>
             <a:r>
-              <a:rPr lang="en-US" smtClean="0"/>
+              <a:rPr lang="en-US"/>
               <a:t>Fourth level</a:t>
             </a:r>
           </a:p>
           <a:p>
             <a:pPr lvl="4"/>
             <a:r>
-              <a:rPr lang="en-US" smtClean="0"/>
+              <a:rPr lang="en-US"/>
               <a:t>Fifth level</a:t>
             </a:r>
-            <a:endParaRPr lang="en-US"/>
           </a:p>
         </p:txBody>
       </p:sp>
@@ -643,7 +653,7 @@
           <a:p>
             <a:fld id="{5BCAD085-E8A6-8845-BD4E-CB4CCA059FC4}" type="datetimeFigureOut">
               <a:rPr lang="en-US" smtClean="0"/>
-              <a:t>1/27/13</a:t>
+              <a:t>5/28/2026</a:t>
             </a:fld>
             <a:endParaRPr lang="en-US"/>
           </a:p>
@@ -737,10 +747,9 @@
           <a:lstStyle/>
           <a:p>
             <a:r>
-              <a:rPr lang="en-US" smtClean="0"/>
+              <a:rPr lang="en-US"/>
               <a:t>Click to edit Master title style</a:t>
             </a:r>
-            <a:endParaRPr lang="en-US"/>
           </a:p>
         </p:txBody>
       </p:sp>
@@ -761,38 +770,37 @@
           <a:p>
             <a:pPr lvl="0"/>
             <a:r>
-              <a:rPr lang="en-US" smtClean="0"/>
+              <a:rPr lang="en-US"/>
               <a:t>Click to edit Master text styles</a:t>
             </a:r>
           </a:p>
           <a:p>
             <a:pPr lvl="1"/>
             <a:r>
-              <a:rPr lang="en-US" smtClean="0"/>
+              <a:rPr lang="en-US"/>
               <a:t>Second level</a:t>
             </a:r>
           </a:p>
           <a:p>
             <a:pPr lvl="2"/>
             <a:r>
-              <a:rPr lang="en-US" smtClean="0"/>
+              <a:rPr lang="en-US"/>
               <a:t>Third level</a:t>
             </a:r>
           </a:p>
           <a:p>
             <a:pPr lvl="3"/>
             <a:r>
-              <a:rPr lang="en-US" smtClean="0"/>
+              <a:rPr lang="en-US"/>
               <a:t>Fourth level</a:t>
             </a:r>
           </a:p>
           <a:p>
             <a:pPr lvl="4"/>
             <a:r>
-              <a:rPr lang="en-US" smtClean="0"/>
+              <a:rPr lang="en-US"/>
               <a:t>Fifth level</a:t>
             </a:r>
-            <a:endParaRPr lang="en-US"/>
           </a:p>
         </p:txBody>
       </p:sp>
@@ -813,7 +821,7 @@
           <a:p>
             <a:fld id="{5BCAD085-E8A6-8845-BD4E-CB4CCA059FC4}" type="datetimeFigureOut">
               <a:rPr lang="en-US" smtClean="0"/>
-              <a:t>1/27/13</a:t>
+              <a:t>5/28/2026</a:t>
             </a:fld>
             <a:endParaRPr lang="en-US"/>
           </a:p>
@@ -916,10 +924,9 @@
           </a:lstStyle>
           <a:p>
             <a:r>
-              <a:rPr lang="en-US" smtClean="0"/>
+              <a:rPr lang="en-US"/>
               <a:t>Click to edit Master title style</a:t>
             </a:r>
-            <a:endParaRPr lang="en-US"/>
           </a:p>
         </p:txBody>
       </p:sp>
@@ -1036,7 +1043,7 @@
           <a:p>
             <a:pPr lvl="0"/>
             <a:r>
-              <a:rPr lang="en-US" smtClean="0"/>
+              <a:rPr lang="en-US"/>
               <a:t>Click to edit Master text styles</a:t>
             </a:r>
           </a:p>
@@ -1059,7 +1066,7 @@
           <a:p>
             <a:fld id="{5BCAD085-E8A6-8845-BD4E-CB4CCA059FC4}" type="datetimeFigureOut">
               <a:rPr lang="en-US" smtClean="0"/>
-              <a:t>1/27/13</a:t>
+              <a:t>5/28/2026</a:t>
             </a:fld>
             <a:endParaRPr lang="en-US"/>
           </a:p>
@@ -1153,10 +1160,9 @@
           <a:lstStyle/>
           <a:p>
             <a:r>
-              <a:rPr lang="en-US" smtClean="0"/>
+              <a:rPr lang="en-US"/>
               <a:t>Click to edit Master title style</a:t>
             </a:r>
-            <a:endParaRPr lang="en-US"/>
           </a:p>
         </p:txBody>
       </p:sp>
@@ -1210,38 +1216,37 @@
           <a:p>
             <a:pPr lvl="0"/>
             <a:r>
-              <a:rPr lang="en-US" smtClean="0"/>
+              <a:rPr lang="en-US"/>
               <a:t>Click to edit Master text styles</a:t>
             </a:r>
           </a:p>
           <a:p>
             <a:pPr lvl="1"/>
             <a:r>
-              <a:rPr lang="en-US" smtClean="0"/>
+              <a:rPr lang="en-US"/>
               <a:t>Second level</a:t>
             </a:r>
           </a:p>
           <a:p>
             <a:pPr lvl="2"/>
             <a:r>
-              <a:rPr lang="en-US" smtClean="0"/>
+              <a:rPr lang="en-US"/>
               <a:t>Third level</a:t>
             </a:r>
           </a:p>
           <a:p>
             <a:pPr lvl="3"/>
             <a:r>
-              <a:rPr lang="en-US" smtClean="0"/>
+              <a:rPr lang="en-US"/>
               <a:t>Fourth level</a:t>
             </a:r>
           </a:p>
           <a:p>
             <a:pPr lvl="4"/>
             <a:r>
-              <a:rPr lang="en-US" smtClean="0"/>
+              <a:rPr lang="en-US"/>
               <a:t>Fifth level</a:t>
             </a:r>
-            <a:endParaRPr lang="en-US"/>
           </a:p>
         </p:txBody>
       </p:sp>
@@ -1295,38 +1300,37 @@
           <a:p>
             <a:pPr lvl="0"/>
             <a:r>
-              <a:rPr lang="en-US" smtClean="0"/>
+              <a:rPr lang="en-US"/>
               <a:t>Click to edit Master text styles</a:t>
             </a:r>
           </a:p>
           <a:p>
             <a:pPr lvl="1"/>
             <a:r>
-              <a:rPr lang="en-US" smtClean="0"/>
+              <a:rPr lang="en-US"/>
               <a:t>Second level</a:t>
             </a:r>
           </a:p>
           <a:p>
             <a:pPr lvl="2"/>
             <a:r>
-              <a:rPr lang="en-US" smtClean="0"/>
+              <a:rPr lang="en-US"/>
               <a:t>Third level</a:t>
             </a:r>
           </a:p>
           <a:p>
             <a:pPr lvl="3"/>
             <a:r>
-              <a:rPr lang="en-US" smtClean="0"/>
+              <a:rPr lang="en-US"/>
               <a:t>Fourth level</a:t>
             </a:r>
           </a:p>
           <a:p>
             <a:pPr lvl="4"/>
             <a:r>
-              <a:rPr lang="en-US" smtClean="0"/>
+              <a:rPr lang="en-US"/>
               <a:t>Fifth level</a:t>
             </a:r>
-            <a:endParaRPr lang="en-US"/>
           </a:p>
         </p:txBody>
       </p:sp>
@@ -1347,7 +1351,7 @@
           <a:p>
             <a:fld id="{5BCAD085-E8A6-8845-BD4E-CB4CCA059FC4}" type="datetimeFigureOut">
               <a:rPr lang="en-US" smtClean="0"/>
-              <a:t>1/27/13</a:t>
+              <a:t>5/28/2026</a:t>
             </a:fld>
             <a:endParaRPr lang="en-US"/>
           </a:p>
@@ -1445,10 +1449,9 @@
           </a:lstStyle>
           <a:p>
             <a:r>
-              <a:rPr lang="en-US" smtClean="0"/>
+              <a:rPr lang="en-US"/>
               <a:t>Click to edit Master title style</a:t>
             </a:r>
-            <a:endParaRPr lang="en-US"/>
           </a:p>
         </p:txBody>
       </p:sp>
@@ -1511,7 +1514,7 @@
           <a:p>
             <a:pPr lvl="0"/>
             <a:r>
-              <a:rPr lang="en-US" smtClean="0"/>
+              <a:rPr lang="en-US"/>
               <a:t>Click to edit Master text styles</a:t>
             </a:r>
           </a:p>
@@ -1567,38 +1570,37 @@
           <a:p>
             <a:pPr lvl="0"/>
             <a:r>
-              <a:rPr lang="en-US" smtClean="0"/>
+              <a:rPr lang="en-US"/>
               <a:t>Click to edit Master text styles</a:t>
             </a:r>
           </a:p>
           <a:p>
             <a:pPr lvl="1"/>
             <a:r>
-              <a:rPr lang="en-US" smtClean="0"/>
+              <a:rPr lang="en-US"/>
               <a:t>Second level</a:t>
             </a:r>
           </a:p>
           <a:p>
             <a:pPr lvl="2"/>
             <a:r>
-              <a:rPr lang="en-US" smtClean="0"/>
+              <a:rPr lang="en-US"/>
               <a:t>Third level</a:t>
             </a:r>
           </a:p>
           <a:p>
             <a:pPr lvl="3"/>
             <a:r>
-              <a:rPr lang="en-US" smtClean="0"/>
+              <a:rPr lang="en-US"/>
               <a:t>Fourth level</a:t>
             </a:r>
           </a:p>
           <a:p>
             <a:pPr lvl="4"/>
             <a:r>
-              <a:rPr lang="en-US" smtClean="0"/>
+              <a:rPr lang="en-US"/>
               <a:t>Fifth level</a:t>
             </a:r>
-            <a:endParaRPr lang="en-US"/>
           </a:p>
         </p:txBody>
       </p:sp>
@@ -1661,7 +1663,7 @@
           <a:p>
             <a:pPr lvl="0"/>
             <a:r>
-              <a:rPr lang="en-US" smtClean="0"/>
+              <a:rPr lang="en-US"/>
               <a:t>Click to edit Master text styles</a:t>
             </a:r>
           </a:p>
@@ -1717,38 +1719,37 @@
           <a:p>
             <a:pPr lvl="0"/>
             <a:r>
-              <a:rPr lang="en-US" smtClean="0"/>
+              <a:rPr lang="en-US"/>
               <a:t>Click to edit Master text styles</a:t>
             </a:r>
           </a:p>
           <a:p>
             <a:pPr lvl="1"/>
             <a:r>
-              <a:rPr lang="en-US" smtClean="0"/>
+              <a:rPr lang="en-US"/>
               <a:t>Second level</a:t>
             </a:r>
           </a:p>
           <a:p>
             <a:pPr lvl="2"/>
             <a:r>
-              <a:rPr lang="en-US" smtClean="0"/>
+              <a:rPr lang="en-US"/>
               <a:t>Third level</a:t>
             </a:r>
           </a:p>
           <a:p>
             <a:pPr lvl="3"/>
             <a:r>
-              <a:rPr lang="en-US" smtClean="0"/>
+              <a:rPr lang="en-US"/>
               <a:t>Fourth level</a:t>
             </a:r>
           </a:p>
           <a:p>
             <a:pPr lvl="4"/>
             <a:r>
-              <a:rPr lang="en-US" smtClean="0"/>
+              <a:rPr lang="en-US"/>
               <a:t>Fifth level</a:t>
             </a:r>
-            <a:endParaRPr lang="en-US"/>
           </a:p>
         </p:txBody>
       </p:sp>
@@ -1769,7 +1770,7 @@
           <a:p>
             <a:fld id="{5BCAD085-E8A6-8845-BD4E-CB4CCA059FC4}" type="datetimeFigureOut">
               <a:rPr lang="en-US" smtClean="0"/>
-              <a:t>1/27/13</a:t>
+              <a:t>5/28/2026</a:t>
             </a:fld>
             <a:endParaRPr lang="en-US"/>
           </a:p>
@@ -1863,10 +1864,9 @@
           <a:lstStyle/>
           <a:p>
             <a:r>
-              <a:rPr lang="en-US" smtClean="0"/>
+              <a:rPr lang="en-US"/>
               <a:t>Click to edit Master title style</a:t>
             </a:r>
-            <a:endParaRPr lang="en-US"/>
           </a:p>
         </p:txBody>
       </p:sp>
@@ -1887,7 +1887,7 @@
           <a:p>
             <a:fld id="{5BCAD085-E8A6-8845-BD4E-CB4CCA059FC4}" type="datetimeFigureOut">
               <a:rPr lang="en-US" smtClean="0"/>
-              <a:t>1/27/13</a:t>
+              <a:t>5/28/2026</a:t>
             </a:fld>
             <a:endParaRPr lang="en-US"/>
           </a:p>
@@ -1982,7 +1982,7 @@
           <a:p>
             <a:fld id="{5BCAD085-E8A6-8845-BD4E-CB4CCA059FC4}" type="datetimeFigureOut">
               <a:rPr lang="en-US" smtClean="0"/>
-              <a:t>1/27/13</a:t>
+              <a:t>5/28/2026</a:t>
             </a:fld>
             <a:endParaRPr lang="en-US"/>
           </a:p>
@@ -2085,10 +2085,9 @@
           </a:lstStyle>
           <a:p>
             <a:r>
-              <a:rPr lang="en-US" smtClean="0"/>
+              <a:rPr lang="en-US"/>
               <a:t>Click to edit Master title style</a:t>
             </a:r>
-            <a:endParaRPr lang="en-US"/>
           </a:p>
         </p:txBody>
       </p:sp>
@@ -2142,38 +2141,37 @@
           <a:p>
             <a:pPr lvl="0"/>
             <a:r>
-              <a:rPr lang="en-US" smtClean="0"/>
+              <a:rPr lang="en-US"/>
               <a:t>Click to edit Master text styles</a:t>
             </a:r>
           </a:p>
           <a:p>
             <a:pPr lvl="1"/>
             <a:r>
-              <a:rPr lang="en-US" smtClean="0"/>
+              <a:rPr lang="en-US"/>
               <a:t>Second level</a:t>
             </a:r>
           </a:p>
           <a:p>
             <a:pPr lvl="2"/>
             <a:r>
-              <a:rPr lang="en-US" smtClean="0"/>
+              <a:rPr lang="en-US"/>
               <a:t>Third level</a:t>
             </a:r>
           </a:p>
           <a:p>
             <a:pPr lvl="3"/>
             <a:r>
-              <a:rPr lang="en-US" smtClean="0"/>
+              <a:rPr lang="en-US"/>
               <a:t>Fourth level</a:t>
             </a:r>
           </a:p>
           <a:p>
             <a:pPr lvl="4"/>
             <a:r>
-              <a:rPr lang="en-US" smtClean="0"/>
+              <a:rPr lang="en-US"/>
               <a:t>Fifth level</a:t>
             </a:r>
-            <a:endParaRPr lang="en-US"/>
           </a:p>
         </p:txBody>
       </p:sp>
@@ -2236,7 +2234,7 @@
           <a:p>
             <a:pPr lvl="0"/>
             <a:r>
-              <a:rPr lang="en-US" smtClean="0"/>
+              <a:rPr lang="en-US"/>
               <a:t>Click to edit Master text styles</a:t>
             </a:r>
           </a:p>
@@ -2259,7 +2257,7 @@
           <a:p>
             <a:fld id="{5BCAD085-E8A6-8845-BD4E-CB4CCA059FC4}" type="datetimeFigureOut">
               <a:rPr lang="en-US" smtClean="0"/>
-              <a:t>1/27/13</a:t>
+              <a:t>5/28/2026</a:t>
             </a:fld>
             <a:endParaRPr lang="en-US"/>
           </a:p>
@@ -2362,10 +2360,9 @@
           </a:lstStyle>
           <a:p>
             <a:r>
-              <a:rPr lang="en-US" smtClean="0"/>
+              <a:rPr lang="en-US"/>
               <a:t>Click to edit Master title style</a:t>
             </a:r>
-            <a:endParaRPr lang="en-US"/>
           </a:p>
         </p:txBody>
       </p:sp>
@@ -2489,7 +2486,7 @@
           <a:p>
             <a:pPr lvl="0"/>
             <a:r>
-              <a:rPr lang="en-US" smtClean="0"/>
+              <a:rPr lang="en-US"/>
               <a:t>Click to edit Master text styles</a:t>
             </a:r>
           </a:p>
@@ -2512,7 +2509,7 @@
           <a:p>
             <a:fld id="{5BCAD085-E8A6-8845-BD4E-CB4CCA059FC4}" type="datetimeFigureOut">
               <a:rPr lang="en-US" smtClean="0"/>
-              <a:t>1/27/13</a:t>
+              <a:t>5/28/2026</a:t>
             </a:fld>
             <a:endParaRPr lang="en-US"/>
           </a:p>
@@ -2621,10 +2618,9 @@
           <a:lstStyle/>
           <a:p>
             <a:r>
-              <a:rPr lang="en-US" smtClean="0"/>
+              <a:rPr lang="en-US"/>
               <a:t>Click to edit Master title style</a:t>
             </a:r>
-            <a:endParaRPr lang="en-US"/>
           </a:p>
         </p:txBody>
       </p:sp>
@@ -2655,38 +2651,37 @@
           <a:p>
             <a:pPr lvl="0"/>
             <a:r>
-              <a:rPr lang="en-US" smtClean="0"/>
+              <a:rPr lang="en-US"/>
               <a:t>Click to edit Master text styles</a:t>
             </a:r>
           </a:p>
           <a:p>
             <a:pPr lvl="1"/>
             <a:r>
-              <a:rPr lang="en-US" smtClean="0"/>
+              <a:rPr lang="en-US"/>
               <a:t>Second level</a:t>
             </a:r>
           </a:p>
           <a:p>
             <a:pPr lvl="2"/>
             <a:r>
-              <a:rPr lang="en-US" smtClean="0"/>
+              <a:rPr lang="en-US"/>
               <a:t>Third level</a:t>
             </a:r>
           </a:p>
           <a:p>
             <a:pPr lvl="3"/>
             <a:r>
-              <a:rPr lang="en-US" smtClean="0"/>
+              <a:rPr lang="en-US"/>
               <a:t>Fourth level</a:t>
             </a:r>
           </a:p>
           <a:p>
             <a:pPr lvl="4"/>
             <a:r>
-              <a:rPr lang="en-US" smtClean="0"/>
+              <a:rPr lang="en-US"/>
               <a:t>Fifth level</a:t>
             </a:r>
-            <a:endParaRPr lang="en-US"/>
           </a:p>
         </p:txBody>
       </p:sp>
@@ -2725,7 +2720,7 @@
           <a:p>
             <a:fld id="{5BCAD085-E8A6-8845-BD4E-CB4CCA059FC4}" type="datetimeFigureOut">
               <a:rPr lang="en-US" smtClean="0"/>
-              <a:t>1/27/13</a:t>
+              <a:t>5/28/2026</a:t>
             </a:fld>
             <a:endParaRPr lang="en-US"/>
           </a:p>
@@ -3084,7 +3079,7 @@
 </file>
 
 <file path=ppt/slides/slide1.xml><?xml version="1.0" encoding="utf-8"?>
-<p:sld xmlns:a="http://schemas.openxmlformats.org/drawingml/2006/main" xmlns:p="http://schemas.openxmlformats.org/presentationml/2006/main" xmlns:r="http://schemas.openxmlformats.org/officeDocument/2006/relationships">
+<p:sld xmlns:a="http://schemas.openxmlformats.org/drawingml/2006/main" xmlns:r="http://schemas.openxmlformats.org/officeDocument/2006/relationships" xmlns:p="http://schemas.openxmlformats.org/presentationml/2006/main">
   <p:cSld>
     <p:spTree>
       <p:nvGrpSpPr>
@@ -3092,50 +3087,14 @@
         <p:cNvGrpSpPr/>
         <p:nvPr/>
       </p:nvGrpSpPr>
-      <p:grpSpPr/>
-      <p:sp>
-        <p:nvSpPr>
-          <p:cNvPr id="2" name="Rectangle 1"/>
-          <p:cNvSpPr/>
-          <p:nvPr/>
-        </p:nvSpPr>
-        <p:spPr>
-          <a:xfrm>
-            <a:off x="0" y="0"/>
-            <a:ext cx="12191695" cy="6858000"/>
-          </a:xfrm>
-          <a:prstGeom prst="rect">
-            <a:avLst/>
-          </a:prstGeom>
-          <a:solidFill>
-            <a:srgbClr val="0B2E4F"/>
-          </a:solidFill>
-          <a:ln>
-            <a:noFill/>
-          </a:ln>
-        </p:spPr>
-        <p:style>
-          <a:lnRef idx="1">
-            <a:schemeClr val="accent1"/>
-          </a:lnRef>
-          <a:fillRef idx="3">
-            <a:schemeClr val="accent1"/>
-          </a:fillRef>
-          <a:effectRef idx="2">
-            <a:schemeClr val="accent1"/>
-          </a:effectRef>
-          <a:fontRef idx="minor">
-            <a:schemeClr val="lt1"/>
-          </a:fontRef>
-        </p:style>
-        <p:txBody>
-          <a:bodyPr rtlCol="0" anchor="ctr"/>
-          <a:lstStyle/>
-          <a:p>
-            <a:pPr algn="ctr"/>
-          </a:p>
-        </p:txBody>
-      </p:sp>
+      <p:grpSpPr>
+        <a:xfrm>
+          <a:off x="0" y="0"/>
+          <a:ext cx="0" cy="0"/>
+          <a:chOff x="0" y="0"/>
+          <a:chExt cx="0" cy="0"/>
+        </a:xfrm>
+      </p:grpSpPr>
       <p:sp>
         <p:nvSpPr>
           <p:cNvPr id="3" name="TextBox 2"/>
@@ -3145,7 +3104,7 @@
         <p:spPr>
           <a:xfrm>
             <a:off x="548640" y="2194560"/>
-            <a:ext cx="10972800" cy="1097280"/>
+            <a:ext cx="10972800" cy="769441"/>
           </a:xfrm>
           <a:prstGeom prst="rect">
             <a:avLst/>
@@ -3160,10 +3119,7 @@
           <a:p>
             <a:pPr algn="l"/>
             <a:r>
-              <a:rPr sz="4400" b="1">
-                <a:solidFill>
-                  <a:srgbClr val="FFFFFF"/>
-                </a:solidFill>
+              <a:rPr sz="4400" b="1" dirty="0">
                 <a:latin typeface="Calibri"/>
               </a:rPr>
               <a:t>Clustering de Palmer Penguins</a:t>
@@ -3180,7 +3136,7 @@
         <p:spPr>
           <a:xfrm>
             <a:off x="548640" y="3200400"/>
-            <a:ext cx="10972800" cy="731520"/>
+            <a:ext cx="10972800" cy="1785104"/>
           </a:xfrm>
           <a:prstGeom prst="rect">
             <a:avLst/>
@@ -3195,14 +3151,59 @@
           <a:p>
             <a:pPr algn="l"/>
             <a:r>
-              <a:rPr sz="2200" b="0">
-                <a:solidFill>
-                  <a:srgbClr val="CCDDEE"/>
-                </a:solidFill>
-                <a:latin typeface="Calibri"/>
-              </a:rPr>
-              <a:t>Comparación de K-Means, DBSCAN y Agglomerative Clustering</a:t>
-            </a:r>
+              <a:rPr sz="2200" b="0" dirty="0" err="1">
+                <a:latin typeface="Calibri"/>
+              </a:rPr>
+              <a:t>Comparación</a:t>
+            </a:r>
+            <a:r>
+              <a:rPr sz="2200" b="0" dirty="0">
+                <a:latin typeface="Calibri"/>
+              </a:rPr>
+              <a:t> de K-Means, DBSCAN y Agglomerative Clustering</a:t>
+            </a:r>
+            <a:endParaRPr lang="en-US" sz="2200" b="0" dirty="0">
+              <a:latin typeface="Calibri"/>
+            </a:endParaRPr>
+          </a:p>
+          <a:p>
+            <a:pPr algn="l"/>
+            <a:endParaRPr lang="en-US" sz="2200" dirty="0">
+              <a:latin typeface="Calibri"/>
+            </a:endParaRPr>
+          </a:p>
+          <a:p>
+            <a:pPr algn="l"/>
+            <a:r>
+              <a:rPr lang="en-US" sz="2200" dirty="0">
+                <a:latin typeface="Calibri"/>
+              </a:rPr>
+              <a:t>MINERIA DE DATOS – SAMUEL HIRAM CASTRO MARTINEZ</a:t>
+            </a:r>
+          </a:p>
+          <a:p>
+            <a:pPr algn="l"/>
+            <a:endParaRPr lang="en-US" sz="2200" b="0" dirty="0">
+              <a:latin typeface="Calibri"/>
+            </a:endParaRPr>
+          </a:p>
+          <a:p>
+            <a:pPr algn="l"/>
+            <a:r>
+              <a:rPr lang="en-US" sz="2200" b="0" dirty="0">
+                <a:latin typeface="Calibri"/>
+              </a:rPr>
+              <a:t>Dr.</a:t>
+            </a:r>
+            <a:r>
+              <a:rPr lang="en-US" sz="2200" dirty="0">
+                <a:latin typeface="Calibri"/>
+              </a:rPr>
+              <a:t> Mario Garcia Estrada</a:t>
+            </a:r>
+            <a:endParaRPr lang="en-US" sz="2200" b="0" dirty="0">
+              <a:latin typeface="Calibri"/>
+            </a:endParaRPr>
           </a:p>
         </p:txBody>
       </p:sp>
@@ -3215,7 +3216,7 @@
         <p:spPr>
           <a:xfrm>
             <a:off x="548640" y="5029200"/>
-            <a:ext cx="10972800" cy="457200"/>
+            <a:ext cx="10972800" cy="369332"/>
           </a:xfrm>
           <a:prstGeom prst="rect">
             <a:avLst/>
@@ -3231,9 +3232,6 @@
             <a:pPr algn="l"/>
             <a:r>
               <a:rPr sz="1800" b="0">
-                <a:solidFill>
-                  <a:srgbClr val="AABBCC"/>
-                </a:solidFill>
                 <a:latin typeface="Calibri"/>
               </a:rPr>
               <a:t>Proyecto de Minería de Datos — 26 de mayo de 2026</a:t>
@@ -3250,7 +3248,7 @@
         <p:spPr>
           <a:xfrm>
             <a:off x="548640" y="5486400"/>
-            <a:ext cx="10972800" cy="457200"/>
+            <a:ext cx="10972800" cy="307777"/>
           </a:xfrm>
           <a:prstGeom prst="rect">
             <a:avLst/>
@@ -3266,9 +3264,6 @@
             <a:pPr algn="l"/>
             <a:r>
               <a:rPr sz="1400" b="0">
-                <a:solidFill>
-                  <a:srgbClr val="99AABB"/>
-                </a:solidFill>
                 <a:latin typeface="Calibri"/>
               </a:rPr>
               <a:t>Práctica de Ciencia 2.0 · datos abiertos · código reproducible</a:t>
@@ -3276,6 +3271,66 @@
           </a:p>
         </p:txBody>
       </p:sp>
+      <p:pic>
+        <p:nvPicPr>
+          <p:cNvPr id="10" name="Picture 9">
+            <a:extLst>
+              <a:ext uri="{FF2B5EF4-FFF2-40B4-BE49-F238E27FC236}">
+                <a16:creationId xmlns:a16="http://schemas.microsoft.com/office/drawing/2014/main" id="{91D992CE-7F89-A6E2-3B0D-2FBFC60EB996}"/>
+              </a:ext>
+            </a:extLst>
+          </p:cNvPr>
+          <p:cNvPicPr>
+            <a:picLocks noChangeAspect="1"/>
+          </p:cNvPicPr>
+          <p:nvPr/>
+        </p:nvPicPr>
+        <p:blipFill>
+          <a:blip r:embed="rId2"/>
+          <a:stretch>
+            <a:fillRect/>
+          </a:stretch>
+        </p:blipFill>
+        <p:spPr>
+          <a:xfrm>
+            <a:off x="548640" y="486996"/>
+            <a:ext cx="6775850" cy="1332512"/>
+          </a:xfrm>
+          <a:prstGeom prst="rect">
+            <a:avLst/>
+          </a:prstGeom>
+        </p:spPr>
+      </p:pic>
+      <p:pic>
+        <p:nvPicPr>
+          <p:cNvPr id="11" name="Picture 10" descr="MAESTRIA EN CIENCIAS DE LA COMPUTACION_HEADING">
+            <a:extLst>
+              <a:ext uri="{FF2B5EF4-FFF2-40B4-BE49-F238E27FC236}">
+                <a16:creationId xmlns:a16="http://schemas.microsoft.com/office/drawing/2014/main" id="{2D6CC91A-5FFD-D260-F229-CBB1EB9D61CC}"/>
+              </a:ext>
+            </a:extLst>
+          </p:cNvPr>
+          <p:cNvPicPr>
+            <a:picLocks noChangeAspect="1"/>
+          </p:cNvPicPr>
+          <p:nvPr/>
+        </p:nvPicPr>
+        <p:blipFill>
+          <a:blip r:embed="rId3"/>
+          <a:stretch>
+            <a:fillRect/>
+          </a:stretch>
+        </p:blipFill>
+        <p:spPr>
+          <a:xfrm>
+            <a:off x="8644942" y="5398532"/>
+            <a:ext cx="2998418" cy="983856"/>
+          </a:xfrm>
+          <a:prstGeom prst="rect">
+            <a:avLst/>
+          </a:prstGeom>
+        </p:spPr>
+      </p:pic>
     </p:spTree>
   </p:cSld>
   <p:clrMapOvr>
@@ -3285,7 +3340,7 @@
 </file>
 
 <file path=ppt/slides/slide2.xml><?xml version="1.0" encoding="utf-8"?>
-<p:sld xmlns:a="http://schemas.openxmlformats.org/drawingml/2006/main" xmlns:p="http://schemas.openxmlformats.org/presentationml/2006/main" xmlns:r="http://schemas.openxmlformats.org/officeDocument/2006/relationships">
+<p:sld xmlns:a="http://schemas.openxmlformats.org/drawingml/2006/main" xmlns:r="http://schemas.openxmlformats.org/officeDocument/2006/relationships" xmlns:p="http://schemas.openxmlformats.org/presentationml/2006/main">
   <p:cSld>
     <p:spTree>
       <p:nvGrpSpPr>
@@ -3293,7 +3348,14 @@
         <p:cNvGrpSpPr/>
         <p:nvPr/>
       </p:nvGrpSpPr>
-      <p:grpSpPr/>
+      <p:grpSpPr>
+        <a:xfrm>
+          <a:off x="0" y="0"/>
+          <a:ext cx="0" cy="0"/>
+          <a:chOff x="0" y="0"/>
+          <a:chExt cx="0" cy="0"/>
+        </a:xfrm>
+      </p:grpSpPr>
       <p:sp>
         <p:nvSpPr>
           <p:cNvPr id="2" name="Rectangle 1"/>
@@ -3334,6 +3396,7 @@
           <a:lstStyle/>
           <a:p>
             <a:pPr algn="ctr"/>
+            <a:endParaRPr/>
           </a:p>
         </p:txBody>
       </p:sp>
@@ -3450,7 +3513,7 @@
         </p:nvSpPr>
         <p:spPr>
           <a:xfrm>
-            <a:off x="365760" y="2834640"/>
+            <a:off x="380847" y="2286000"/>
             <a:ext cx="11430000" cy="457200"/>
           </a:xfrm>
           <a:prstGeom prst="rect">
@@ -3466,7 +3529,7 @@
           <a:p>
             <a:pPr algn="l"/>
             <a:r>
-              <a:rPr sz="2200" b="1">
+              <a:rPr sz="2200" b="1" dirty="0" err="1">
                 <a:solidFill>
                   <a:srgbClr val="1F77B4"/>
                 </a:solidFill>
@@ -3474,6 +3537,12 @@
               </a:rPr>
               <a:t>Objetivo</a:t>
             </a:r>
+            <a:endParaRPr sz="2200" b="1" dirty="0">
+              <a:solidFill>
+                <a:srgbClr val="1F77B4"/>
+              </a:solidFill>
+              <a:latin typeface="Calibri"/>
+            </a:endParaRPr>
           </a:p>
         </p:txBody>
       </p:sp>
@@ -3485,8 +3554,8 @@
         </p:nvSpPr>
         <p:spPr>
           <a:xfrm>
-            <a:off x="548640" y="3337560"/>
-            <a:ext cx="10972800" cy="2286000"/>
+            <a:off x="548639" y="2784596"/>
+            <a:ext cx="11085641" cy="1077218"/>
           </a:xfrm>
           <a:prstGeom prst="rect">
             <a:avLst/>
@@ -3505,13 +3574,67 @@
               </a:spcAft>
             </a:pPr>
             <a:r>
-              <a:rPr sz="1800">
-                <a:solidFill>
-                  <a:srgbClr val="222222"/>
-                </a:solidFill>
-                <a:latin typeface="Calibri"/>
-              </a:rPr>
-              <a:t>• Comparar 3 algoritmos de clustering no supervisado: K-Means, DBSCAN y Agglomerative.</a:t>
+              <a:rPr sz="1800" dirty="0">
+                <a:solidFill>
+                  <a:srgbClr val="222222"/>
+                </a:solidFill>
+                <a:latin typeface="Calibri"/>
+              </a:rPr>
+              <a:t>• </a:t>
+            </a:r>
+            <a:r>
+              <a:rPr sz="1800" dirty="0" err="1">
+                <a:solidFill>
+                  <a:srgbClr val="222222"/>
+                </a:solidFill>
+                <a:latin typeface="Calibri"/>
+              </a:rPr>
+              <a:t>Comparar</a:t>
+            </a:r>
+            <a:r>
+              <a:rPr sz="1800" dirty="0">
+                <a:solidFill>
+                  <a:srgbClr val="222222"/>
+                </a:solidFill>
+                <a:latin typeface="Calibri"/>
+              </a:rPr>
+              <a:t> 3 </a:t>
+            </a:r>
+            <a:r>
+              <a:rPr sz="1800" dirty="0" err="1">
+                <a:solidFill>
+                  <a:srgbClr val="222222"/>
+                </a:solidFill>
+                <a:latin typeface="Calibri"/>
+              </a:rPr>
+              <a:t>algoritmos</a:t>
+            </a:r>
+            <a:r>
+              <a:rPr sz="1800" dirty="0">
+                <a:solidFill>
+                  <a:srgbClr val="222222"/>
+                </a:solidFill>
+                <a:latin typeface="Calibri"/>
+              </a:rPr>
+              <a:t> de clustering no </a:t>
+            </a:r>
+            <a:r>
+              <a:rPr sz="1800" dirty="0" err="1">
+                <a:solidFill>
+                  <a:srgbClr val="222222"/>
+                </a:solidFill>
+                <a:latin typeface="Calibri"/>
+              </a:rPr>
+              <a:t>supervisado</a:t>
+            </a:r>
+            <a:r>
+              <a:rPr sz="1800" dirty="0">
+                <a:solidFill>
+                  <a:srgbClr val="222222"/>
+                </a:solidFill>
+                <a:latin typeface="Calibri"/>
+              </a:rPr>
+              <a:t>: K-Means, DBSCAN y Agglomerative.</a:t>
             </a:r>
           </a:p>
           <a:p>
@@ -3521,13 +3644,67 @@
               </a:spcAft>
             </a:pPr>
             <a:r>
-              <a:rPr sz="1800">
-                <a:solidFill>
-                  <a:srgbClr val="222222"/>
-                </a:solidFill>
-                <a:latin typeface="Calibri"/>
-              </a:rPr>
-              <a:t>• Evaluar con métricas interna (Silhouette) y externa (Adjusted Rand Index vs. especie).</a:t>
+              <a:rPr sz="1800" dirty="0">
+                <a:solidFill>
+                  <a:srgbClr val="222222"/>
+                </a:solidFill>
+                <a:latin typeface="Calibri"/>
+              </a:rPr>
+              <a:t>• </a:t>
+            </a:r>
+            <a:r>
+              <a:rPr sz="1800" dirty="0" err="1">
+                <a:solidFill>
+                  <a:srgbClr val="222222"/>
+                </a:solidFill>
+                <a:latin typeface="Calibri"/>
+              </a:rPr>
+              <a:t>Evaluar</a:t>
+            </a:r>
+            <a:r>
+              <a:rPr sz="1800" dirty="0">
+                <a:solidFill>
+                  <a:srgbClr val="222222"/>
+                </a:solidFill>
+                <a:latin typeface="Calibri"/>
+              </a:rPr>
+              <a:t> con </a:t>
+            </a:r>
+            <a:r>
+              <a:rPr sz="1800" dirty="0" err="1">
+                <a:solidFill>
+                  <a:srgbClr val="222222"/>
+                </a:solidFill>
+                <a:latin typeface="Calibri"/>
+              </a:rPr>
+              <a:t>métricas</a:t>
+            </a:r>
+            <a:r>
+              <a:rPr sz="1800" dirty="0">
+                <a:solidFill>
+                  <a:srgbClr val="222222"/>
+                </a:solidFill>
+                <a:latin typeface="Calibri"/>
+              </a:rPr>
+              <a:t> interna (Silhouette) y externa (Adjusted Rand Index vs. </a:t>
+            </a:r>
+            <a:r>
+              <a:rPr sz="1800" dirty="0" err="1">
+                <a:solidFill>
+                  <a:srgbClr val="222222"/>
+                </a:solidFill>
+                <a:latin typeface="Calibri"/>
+              </a:rPr>
+              <a:t>especie</a:t>
+            </a:r>
+            <a:r>
+              <a:rPr sz="1800" dirty="0">
+                <a:solidFill>
+                  <a:srgbClr val="222222"/>
+                </a:solidFill>
+                <a:latin typeface="Calibri"/>
+              </a:rPr>
+              <a:t>).</a:t>
             </a:r>
           </a:p>
           <a:p>
@@ -3537,13 +3714,121 @@
               </a:spcAft>
             </a:pPr>
             <a:r>
-              <a:rPr sz="1800">
-                <a:solidFill>
-                  <a:srgbClr val="222222"/>
-                </a:solidFill>
-                <a:latin typeface="Calibri"/>
-              </a:rPr>
-              <a:t>• Demostrar un flujo completo de minería de datos siguiendo Ciencia 2.0.</a:t>
+              <a:rPr sz="1800" dirty="0">
+                <a:solidFill>
+                  <a:srgbClr val="222222"/>
+                </a:solidFill>
+                <a:latin typeface="Calibri"/>
+              </a:rPr>
+              <a:t>• </a:t>
+            </a:r>
+            <a:r>
+              <a:rPr sz="1800" dirty="0" err="1">
+                <a:solidFill>
+                  <a:srgbClr val="222222"/>
+                </a:solidFill>
+                <a:latin typeface="Calibri"/>
+              </a:rPr>
+              <a:t>Demostrar</a:t>
+            </a:r>
+            <a:r>
+              <a:rPr sz="1800" dirty="0">
+                <a:solidFill>
+                  <a:srgbClr val="222222"/>
+                </a:solidFill>
+                <a:latin typeface="Calibri"/>
+              </a:rPr>
+              <a:t> un </a:t>
+            </a:r>
+            <a:r>
+              <a:rPr sz="1800" dirty="0" err="1">
+                <a:solidFill>
+                  <a:srgbClr val="222222"/>
+                </a:solidFill>
+                <a:latin typeface="Calibri"/>
+              </a:rPr>
+              <a:t>flujo</a:t>
+            </a:r>
+            <a:r>
+              <a:rPr sz="1800" dirty="0">
+                <a:solidFill>
+                  <a:srgbClr val="222222"/>
+                </a:solidFill>
+                <a:latin typeface="Calibri"/>
+              </a:rPr>
+              <a:t> </a:t>
+            </a:r>
+            <a:r>
+              <a:rPr sz="1800" dirty="0" err="1">
+                <a:solidFill>
+                  <a:srgbClr val="222222"/>
+                </a:solidFill>
+                <a:latin typeface="Calibri"/>
+              </a:rPr>
+              <a:t>completo</a:t>
+            </a:r>
+            <a:r>
+              <a:rPr sz="1800" dirty="0">
+                <a:solidFill>
+                  <a:srgbClr val="222222"/>
+                </a:solidFill>
+                <a:latin typeface="Calibri"/>
+              </a:rPr>
+              <a:t> de </a:t>
+            </a:r>
+            <a:r>
+              <a:rPr sz="1800" dirty="0" err="1">
+                <a:solidFill>
+                  <a:srgbClr val="222222"/>
+                </a:solidFill>
+                <a:latin typeface="Calibri"/>
+              </a:rPr>
+              <a:t>minería</a:t>
+            </a:r>
+            <a:r>
+              <a:rPr sz="1800" dirty="0">
+                <a:solidFill>
+                  <a:srgbClr val="222222"/>
+                </a:solidFill>
+                <a:latin typeface="Calibri"/>
+              </a:rPr>
+              <a:t> de </a:t>
+            </a:r>
+            <a:r>
+              <a:rPr sz="1800" dirty="0" err="1">
+                <a:solidFill>
+                  <a:srgbClr val="222222"/>
+                </a:solidFill>
+                <a:latin typeface="Calibri"/>
+              </a:rPr>
+              <a:t>datos</a:t>
+            </a:r>
+            <a:r>
+              <a:rPr sz="1800" dirty="0">
+                <a:solidFill>
+                  <a:srgbClr val="222222"/>
+                </a:solidFill>
+                <a:latin typeface="Calibri"/>
+              </a:rPr>
+              <a:t> </a:t>
+            </a:r>
+            <a:r>
+              <a:rPr sz="1800" dirty="0" err="1">
+                <a:solidFill>
+                  <a:srgbClr val="222222"/>
+                </a:solidFill>
+                <a:latin typeface="Calibri"/>
+              </a:rPr>
+              <a:t>siguiendo</a:t>
+            </a:r>
+            <a:r>
+              <a:rPr sz="1800" dirty="0">
+                <a:solidFill>
+                  <a:srgbClr val="222222"/>
+                </a:solidFill>
+                <a:latin typeface="Calibri"/>
+              </a:rPr>
+              <a:t> Ciencia 2.0.</a:t>
             </a:r>
           </a:p>
         </p:txBody>
@@ -3583,6 +3868,364 @@
           </a:p>
         </p:txBody>
       </p:sp>
+      <p:sp>
+        <p:nvSpPr>
+          <p:cNvPr id="9" name="TextBox 8">
+            <a:extLst>
+              <a:ext uri="{FF2B5EF4-FFF2-40B4-BE49-F238E27FC236}">
+                <a16:creationId xmlns:a16="http://schemas.microsoft.com/office/drawing/2014/main" id="{D4A16B13-202C-2A1C-DDD6-FF9A788EF2C3}"/>
+              </a:ext>
+            </a:extLst>
+          </p:cNvPr>
+          <p:cNvSpPr txBox="1"/>
+          <p:nvPr/>
+        </p:nvSpPr>
+        <p:spPr>
+          <a:xfrm>
+            <a:off x="320040" y="4114800"/>
+            <a:ext cx="11430000" cy="430887"/>
+          </a:xfrm>
+          <a:prstGeom prst="rect">
+            <a:avLst/>
+          </a:prstGeom>
+          <a:noFill/>
+        </p:spPr>
+        <p:txBody>
+          <a:bodyPr wrap="square" lIns="45720" rIns="45720">
+            <a:spAutoFit/>
+          </a:bodyPr>
+          <a:lstStyle/>
+          <a:p>
+            <a:pPr algn="l"/>
+            <a:r>
+              <a:rPr lang="en-US" sz="2200" b="1" dirty="0">
+                <a:solidFill>
+                  <a:srgbClr val="1F77B4"/>
+                </a:solidFill>
+                <a:latin typeface="Calibri"/>
+              </a:rPr>
+              <a:t>Tipo de </a:t>
+            </a:r>
+            <a:r>
+              <a:rPr lang="en-US" sz="2200" b="1" dirty="0" err="1">
+                <a:solidFill>
+                  <a:srgbClr val="1F77B4"/>
+                </a:solidFill>
+                <a:latin typeface="Calibri"/>
+              </a:rPr>
+              <a:t>aprendizaje</a:t>
+            </a:r>
+            <a:r>
+              <a:rPr lang="en-US" sz="2200" b="1" dirty="0">
+                <a:solidFill>
+                  <a:srgbClr val="1F77B4"/>
+                </a:solidFill>
+                <a:latin typeface="Calibri"/>
+              </a:rPr>
+              <a:t> </a:t>
+            </a:r>
+            <a:r>
+              <a:rPr lang="en-US" sz="2200" b="1" dirty="0" err="1">
+                <a:solidFill>
+                  <a:srgbClr val="1F77B4"/>
+                </a:solidFill>
+                <a:latin typeface="Calibri"/>
+              </a:rPr>
+              <a:t>computado</a:t>
+            </a:r>
+            <a:r>
+              <a:rPr lang="en-US" sz="2200" b="1" dirty="0">
+                <a:solidFill>
+                  <a:srgbClr val="1F77B4"/>
+                </a:solidFill>
+                <a:latin typeface="Calibri"/>
+              </a:rPr>
+              <a:t> para </a:t>
+            </a:r>
+            <a:r>
+              <a:rPr lang="en-US" sz="2200" b="1" dirty="0" err="1">
+                <a:solidFill>
+                  <a:srgbClr val="1F77B4"/>
+                </a:solidFill>
+                <a:latin typeface="Calibri"/>
+              </a:rPr>
+              <a:t>este</a:t>
+            </a:r>
+            <a:r>
+              <a:rPr lang="en-US" sz="2200" b="1" dirty="0">
+                <a:solidFill>
+                  <a:srgbClr val="1F77B4"/>
+                </a:solidFill>
+                <a:latin typeface="Calibri"/>
+              </a:rPr>
+              <a:t> </a:t>
+            </a:r>
+            <a:r>
+              <a:rPr lang="en-US" sz="2200" b="1" dirty="0" err="1">
+                <a:solidFill>
+                  <a:srgbClr val="1F77B4"/>
+                </a:solidFill>
+                <a:latin typeface="Calibri"/>
+              </a:rPr>
+              <a:t>problema</a:t>
+            </a:r>
+            <a:endParaRPr sz="2200" b="1" dirty="0">
+              <a:solidFill>
+                <a:srgbClr val="1F77B4"/>
+              </a:solidFill>
+              <a:latin typeface="Calibri"/>
+            </a:endParaRPr>
+          </a:p>
+        </p:txBody>
+      </p:sp>
+      <p:sp>
+        <p:nvSpPr>
+          <p:cNvPr id="10" name="TextBox 9">
+            <a:extLst>
+              <a:ext uri="{FF2B5EF4-FFF2-40B4-BE49-F238E27FC236}">
+                <a16:creationId xmlns:a16="http://schemas.microsoft.com/office/drawing/2014/main" id="{AA53DA43-F59F-9DE5-891C-8D9388CF662C}"/>
+              </a:ext>
+            </a:extLst>
+          </p:cNvPr>
+          <p:cNvSpPr txBox="1"/>
+          <p:nvPr/>
+        </p:nvSpPr>
+        <p:spPr>
+          <a:xfrm>
+            <a:off x="548640" y="4652200"/>
+            <a:ext cx="10972800" cy="369332"/>
+          </a:xfrm>
+          <a:prstGeom prst="rect">
+            <a:avLst/>
+          </a:prstGeom>
+          <a:noFill/>
+        </p:spPr>
+        <p:txBody>
+          <a:bodyPr wrap="square">
+            <a:spAutoFit/>
+          </a:bodyPr>
+          <a:lstStyle/>
+          <a:p>
+            <a:pPr>
+              <a:spcAft>
+                <a:spcPts val="600"/>
+              </a:spcAft>
+            </a:pPr>
+            <a:r>
+              <a:rPr lang="en-US" dirty="0">
+                <a:solidFill>
+                  <a:srgbClr val="222222"/>
+                </a:solidFill>
+              </a:rPr>
+              <a:t>• </a:t>
+            </a:r>
+            <a:r>
+              <a:rPr lang="en-US" dirty="0" err="1">
+                <a:solidFill>
+                  <a:srgbClr val="222222"/>
+                </a:solidFill>
+                <a:latin typeface="Calibri"/>
+              </a:rPr>
+              <a:t>Aprendizaje</a:t>
+            </a:r>
+            <a:r>
+              <a:rPr lang="en-US" dirty="0">
+                <a:solidFill>
+                  <a:srgbClr val="222222"/>
+                </a:solidFill>
+                <a:latin typeface="Calibri"/>
+              </a:rPr>
+              <a:t> no </a:t>
+            </a:r>
+            <a:r>
+              <a:rPr lang="en-US" dirty="0" err="1">
+                <a:solidFill>
+                  <a:srgbClr val="222222"/>
+                </a:solidFill>
+                <a:latin typeface="Calibri"/>
+              </a:rPr>
+              <a:t>supervisado</a:t>
+            </a:r>
+            <a:r>
+              <a:rPr lang="en-US" dirty="0">
+                <a:solidFill>
+                  <a:srgbClr val="222222"/>
+                </a:solidFill>
+                <a:latin typeface="Calibri"/>
+              </a:rPr>
+              <a:t>: no. Solo se </a:t>
+            </a:r>
+            <a:r>
+              <a:rPr lang="en-US" dirty="0" err="1">
+                <a:solidFill>
+                  <a:srgbClr val="222222"/>
+                </a:solidFill>
+                <a:latin typeface="Calibri"/>
+              </a:rPr>
+              <a:t>tienen</a:t>
+            </a:r>
+            <a:r>
+              <a:rPr lang="en-US" dirty="0">
+                <a:solidFill>
+                  <a:srgbClr val="222222"/>
+                </a:solidFill>
+                <a:latin typeface="Calibri"/>
+              </a:rPr>
+              <a:t> </a:t>
+            </a:r>
+            <a:r>
+              <a:rPr lang="en-US" dirty="0" err="1">
+                <a:solidFill>
+                  <a:srgbClr val="222222"/>
+                </a:solidFill>
+                <a:latin typeface="Calibri"/>
+              </a:rPr>
+              <a:t>datos</a:t>
+            </a:r>
+            <a:r>
+              <a:rPr lang="en-US" dirty="0">
+                <a:solidFill>
+                  <a:srgbClr val="222222"/>
+                </a:solidFill>
+                <a:latin typeface="Calibri"/>
+              </a:rPr>
+              <a:t> y la </a:t>
+            </a:r>
+            <a:r>
+              <a:rPr lang="en-US" dirty="0" err="1">
+                <a:solidFill>
+                  <a:srgbClr val="222222"/>
+                </a:solidFill>
+                <a:latin typeface="Calibri"/>
+              </a:rPr>
+              <a:t>maquina</a:t>
+            </a:r>
+            <a:r>
+              <a:rPr lang="en-US" dirty="0">
+                <a:solidFill>
+                  <a:srgbClr val="222222"/>
+                </a:solidFill>
+                <a:latin typeface="Calibri"/>
+              </a:rPr>
+              <a:t> </a:t>
+            </a:r>
+            <a:r>
+              <a:rPr lang="en-US" dirty="0" err="1">
+                <a:solidFill>
+                  <a:srgbClr val="222222"/>
+                </a:solidFill>
+                <a:latin typeface="Calibri"/>
+              </a:rPr>
+              <a:t>debe</a:t>
+            </a:r>
+            <a:r>
+              <a:rPr lang="en-US" dirty="0">
+                <a:solidFill>
+                  <a:srgbClr val="222222"/>
+                </a:solidFill>
+                <a:latin typeface="Calibri"/>
+              </a:rPr>
+              <a:t> </a:t>
+            </a:r>
+            <a:r>
+              <a:rPr lang="en-US" dirty="0" err="1">
+                <a:solidFill>
+                  <a:srgbClr val="222222"/>
+                </a:solidFill>
+                <a:latin typeface="Calibri"/>
+              </a:rPr>
+              <a:t>descubrir</a:t>
+            </a:r>
+            <a:r>
+              <a:rPr lang="en-US" dirty="0">
+                <a:solidFill>
+                  <a:srgbClr val="222222"/>
+                </a:solidFill>
+                <a:latin typeface="Calibri"/>
+              </a:rPr>
+              <a:t>  </a:t>
+            </a:r>
+            <a:r>
+              <a:rPr lang="en-US" dirty="0" err="1">
+                <a:solidFill>
+                  <a:srgbClr val="222222"/>
+                </a:solidFill>
+                <a:latin typeface="Calibri"/>
+              </a:rPr>
+              <a:t>patrones</a:t>
+            </a:r>
+            <a:r>
+              <a:rPr lang="en-US" dirty="0">
+                <a:solidFill>
+                  <a:srgbClr val="222222"/>
+                </a:solidFill>
+                <a:latin typeface="Calibri"/>
+              </a:rPr>
+              <a:t> </a:t>
+            </a:r>
+            <a:r>
+              <a:rPr lang="en-US" dirty="0" err="1">
+                <a:solidFill>
+                  <a:srgbClr val="222222"/>
+                </a:solidFill>
+                <a:latin typeface="Calibri"/>
+              </a:rPr>
+              <a:t>por</a:t>
+            </a:r>
+            <a:r>
+              <a:rPr lang="en-US" dirty="0">
+                <a:solidFill>
+                  <a:srgbClr val="222222"/>
+                </a:solidFill>
+                <a:latin typeface="Calibri"/>
+              </a:rPr>
+              <a:t> </a:t>
+            </a:r>
+            <a:r>
+              <a:rPr lang="en-US" dirty="0" err="1">
+                <a:solidFill>
+                  <a:srgbClr val="222222"/>
+                </a:solidFill>
+                <a:latin typeface="Calibri"/>
+              </a:rPr>
+              <a:t>cuenta</a:t>
+            </a:r>
+            <a:r>
+              <a:rPr lang="en-US" dirty="0">
+                <a:solidFill>
+                  <a:srgbClr val="222222"/>
+                </a:solidFill>
+                <a:latin typeface="Calibri"/>
+              </a:rPr>
+              <a:t> </a:t>
+            </a:r>
+            <a:r>
+              <a:rPr lang="en-US" dirty="0" err="1">
+                <a:solidFill>
+                  <a:srgbClr val="222222"/>
+                </a:solidFill>
+                <a:latin typeface="Calibri"/>
+              </a:rPr>
+              <a:t>propia</a:t>
+            </a:r>
+            <a:r>
+              <a:rPr lang="en-US" dirty="0">
+                <a:solidFill>
+                  <a:srgbClr val="222222"/>
+                </a:solidFill>
+                <a:latin typeface="Calibri"/>
+              </a:rPr>
+              <a:t>.</a:t>
+            </a:r>
+            <a:endParaRPr sz="1800" dirty="0">
+              <a:solidFill>
+                <a:srgbClr val="222222"/>
+              </a:solidFill>
+              <a:latin typeface="Calibri"/>
+            </a:endParaRPr>
+          </a:p>
+        </p:txBody>
+      </p:sp>
     </p:spTree>
   </p:cSld>
   <p:clrMapOvr>
@@ -3592,7 +4235,7 @@
 </file>
 
 <file path=ppt/slides/slide3.xml><?xml version="1.0" encoding="utf-8"?>
-<p:sld xmlns:a="http://schemas.openxmlformats.org/drawingml/2006/main" xmlns:p="http://schemas.openxmlformats.org/presentationml/2006/main" xmlns:r="http://schemas.openxmlformats.org/officeDocument/2006/relationships">
+<p:sld xmlns:a="http://schemas.openxmlformats.org/drawingml/2006/main" xmlns:r="http://schemas.openxmlformats.org/officeDocument/2006/relationships" xmlns:p="http://schemas.openxmlformats.org/presentationml/2006/main">
   <p:cSld>
     <p:spTree>
       <p:nvGrpSpPr>
@@ -3600,7 +4243,14 @@
         <p:cNvGrpSpPr/>
         <p:nvPr/>
       </p:nvGrpSpPr>
-      <p:grpSpPr/>
+      <p:grpSpPr>
+        <a:xfrm>
+          <a:off x="0" y="0"/>
+          <a:ext cx="0" cy="0"/>
+          <a:chOff x="0" y="0"/>
+          <a:chExt cx="0" cy="0"/>
+        </a:xfrm>
+      </p:grpSpPr>
       <p:sp>
         <p:nvSpPr>
           <p:cNvPr id="2" name="Rectangle 1"/>
@@ -3641,6 +4291,7 @@
           <a:lstStyle/>
           <a:p>
             <a:pPr algn="ctr"/>
+            <a:endParaRPr/>
           </a:p>
         </p:txBody>
       </p:sp>
@@ -3742,14 +4393,47 @@
               </a:spcAft>
             </a:pPr>
             <a:r>
-              <a:rPr sz="1800">
-                <a:solidFill>
-                  <a:srgbClr val="222222"/>
-                </a:solidFill>
-                <a:latin typeface="Calibri"/>
-              </a:rPr>
-              <a:t>• 344 observaciones · 3 especies</a:t>
-            </a:r>
+              <a:rPr sz="1800" dirty="0">
+                <a:solidFill>
+                  <a:srgbClr val="222222"/>
+                </a:solidFill>
+                <a:latin typeface="Calibri"/>
+              </a:rPr>
+              <a:t>• 344 </a:t>
+            </a:r>
+            <a:r>
+              <a:rPr sz="1800" dirty="0" err="1">
+                <a:solidFill>
+                  <a:srgbClr val="222222"/>
+                </a:solidFill>
+                <a:latin typeface="Calibri"/>
+              </a:rPr>
+              <a:t>observaciones</a:t>
+            </a:r>
+            <a:r>
+              <a:rPr sz="1800" dirty="0">
+                <a:solidFill>
+                  <a:srgbClr val="222222"/>
+                </a:solidFill>
+                <a:latin typeface="Calibri"/>
+              </a:rPr>
+              <a:t> · 3 </a:t>
+            </a:r>
+            <a:r>
+              <a:rPr sz="1800" dirty="0" err="1">
+                <a:solidFill>
+                  <a:srgbClr val="222222"/>
+                </a:solidFill>
+                <a:latin typeface="Calibri"/>
+              </a:rPr>
+              <a:t>especies</a:t>
+            </a:r>
+            <a:endParaRPr sz="1800" dirty="0">
+              <a:solidFill>
+                <a:srgbClr val="222222"/>
+              </a:solidFill>
+              <a:latin typeface="Calibri"/>
+            </a:endParaRPr>
           </a:p>
           <a:p>
             <a:pPr algn="l">
@@ -3758,7 +4442,7 @@
               </a:spcAft>
             </a:pPr>
             <a:r>
-              <a:rPr sz="1800">
+              <a:rPr sz="1800" dirty="0">
                 <a:solidFill>
                   <a:srgbClr val="222222"/>
                 </a:solidFill>
@@ -3774,13 +4458,31 @@
               </a:spcAft>
             </a:pPr>
             <a:r>
-              <a:rPr sz="1800">
-                <a:solidFill>
-                  <a:srgbClr val="222222"/>
-                </a:solidFill>
-                <a:latin typeface="Calibri"/>
-              </a:rPr>
-              <a:t>• 3 islas: Biscoe, Dream, Torgersen</a:t>
+              <a:rPr sz="1800" dirty="0">
+                <a:solidFill>
+                  <a:srgbClr val="222222"/>
+                </a:solidFill>
+                <a:latin typeface="Calibri"/>
+              </a:rPr>
+              <a:t>• 3 </a:t>
+            </a:r>
+            <a:r>
+              <a:rPr sz="1800" dirty="0" err="1">
+                <a:solidFill>
+                  <a:srgbClr val="222222"/>
+                </a:solidFill>
+                <a:latin typeface="Calibri"/>
+              </a:rPr>
+              <a:t>islas</a:t>
+            </a:r>
+            <a:r>
+              <a:rPr sz="1800" dirty="0">
+                <a:solidFill>
+                  <a:srgbClr val="222222"/>
+                </a:solidFill>
+                <a:latin typeface="Calibri"/>
+              </a:rPr>
+              <a:t>: Biscoe, Dream, Torgersen</a:t>
             </a:r>
           </a:p>
           <a:p>
@@ -3790,14 +4492,65 @@
               </a:spcAft>
             </a:pPr>
             <a:r>
-              <a:rPr sz="1800">
-                <a:solidFill>
-                  <a:srgbClr val="222222"/>
-                </a:solidFill>
-                <a:latin typeface="Calibri"/>
-              </a:rPr>
-              <a:t>• Licencia CC-0 — dominio público</a:t>
-            </a:r>
+              <a:rPr sz="1800" dirty="0">
+                <a:solidFill>
+                  <a:srgbClr val="222222"/>
+                </a:solidFill>
+                <a:latin typeface="Calibri"/>
+              </a:rPr>
+              <a:t>• </a:t>
+            </a:r>
+            <a:r>
+              <a:rPr sz="1800" dirty="0" err="1">
+                <a:solidFill>
+                  <a:srgbClr val="222222"/>
+                </a:solidFill>
+                <a:latin typeface="Calibri"/>
+              </a:rPr>
+              <a:t>Licencia</a:t>
+            </a:r>
+            <a:r>
+              <a:rPr sz="1800" dirty="0">
+                <a:solidFill>
+                  <a:srgbClr val="222222"/>
+                </a:solidFill>
+                <a:latin typeface="Calibri"/>
+              </a:rPr>
+              <a:t> CC-0 — </a:t>
+            </a:r>
+            <a:r>
+              <a:rPr sz="1800" dirty="0" err="1">
+                <a:solidFill>
+                  <a:srgbClr val="222222"/>
+                </a:solidFill>
+                <a:latin typeface="Calibri"/>
+              </a:rPr>
+              <a:t>dominio</a:t>
+            </a:r>
+            <a:r>
+              <a:rPr sz="1800" dirty="0">
+                <a:solidFill>
+                  <a:srgbClr val="222222"/>
+                </a:solidFill>
+                <a:latin typeface="Calibri"/>
+              </a:rPr>
+              <a:t> </a:t>
+            </a:r>
+            <a:r>
+              <a:rPr sz="1800" dirty="0" err="1">
+                <a:solidFill>
+                  <a:srgbClr val="222222"/>
+                </a:solidFill>
+                <a:latin typeface="Calibri"/>
+              </a:rPr>
+              <a:t>público</a:t>
+            </a:r>
+            <a:endParaRPr sz="1800" dirty="0">
+              <a:solidFill>
+                <a:srgbClr val="222222"/>
+              </a:solidFill>
+              <a:latin typeface="Calibri"/>
+            </a:endParaRPr>
           </a:p>
           <a:p>
             <a:pPr algn="l">
@@ -3806,14 +4559,47 @@
               </a:spcAft>
             </a:pPr>
             <a:r>
-              <a:rPr sz="1800">
-                <a:solidFill>
-                  <a:srgbClr val="222222"/>
-                </a:solidFill>
-                <a:latin typeface="Calibri"/>
-              </a:rPr>
-              <a:t>• Fuente: github.com/allisonhorst/palmerpenguins</a:t>
-            </a:r>
+              <a:rPr sz="1800" dirty="0">
+                <a:solidFill>
+                  <a:srgbClr val="222222"/>
+                </a:solidFill>
+                <a:latin typeface="Calibri"/>
+              </a:rPr>
+              <a:t>• Fuente: github.com/</a:t>
+            </a:r>
+            <a:r>
+              <a:rPr sz="1800" dirty="0" err="1">
+                <a:solidFill>
+                  <a:srgbClr val="222222"/>
+                </a:solidFill>
+                <a:latin typeface="Calibri"/>
+              </a:rPr>
+              <a:t>allisonhorst</a:t>
+            </a:r>
+            <a:r>
+              <a:rPr sz="1800" dirty="0">
+                <a:solidFill>
+                  <a:srgbClr val="222222"/>
+                </a:solidFill>
+                <a:latin typeface="Calibri"/>
+              </a:rPr>
+              <a:t>/</a:t>
+            </a:r>
+            <a:r>
+              <a:rPr sz="1800" dirty="0" err="1">
+                <a:solidFill>
+                  <a:srgbClr val="222222"/>
+                </a:solidFill>
+                <a:latin typeface="Calibri"/>
+              </a:rPr>
+              <a:t>palmerpenguins</a:t>
+            </a:r>
+            <a:endParaRPr sz="1800" dirty="0">
+              <a:solidFill>
+                <a:srgbClr val="222222"/>
+              </a:solidFill>
+              <a:latin typeface="Calibri"/>
+            </a:endParaRPr>
           </a:p>
         </p:txBody>
       </p:sp>
@@ -3861,7 +4647,7 @@
         <p:spPr>
           <a:xfrm>
             <a:off x="365760" y="4709160"/>
-            <a:ext cx="5760720" cy="1828800"/>
+            <a:ext cx="5760720" cy="1308050"/>
           </a:xfrm>
           <a:prstGeom prst="rect">
             <a:avLst/>
@@ -3880,14 +4666,56 @@
               </a:spcAft>
             </a:pPr>
             <a:r>
-              <a:rPr sz="1600">
-                <a:solidFill>
-                  <a:srgbClr val="222222"/>
-                </a:solidFill>
-                <a:latin typeface="Calibri"/>
-              </a:rPr>
-              <a:t>• bill_length_mm</a:t>
-            </a:r>
+              <a:rPr sz="1600" dirty="0">
+                <a:solidFill>
+                  <a:srgbClr val="222222"/>
+                </a:solidFill>
+                <a:latin typeface="Calibri"/>
+              </a:rPr>
+              <a:t>• </a:t>
+            </a:r>
+            <a:r>
+              <a:rPr sz="1600" dirty="0" err="1">
+                <a:solidFill>
+                  <a:srgbClr val="222222"/>
+                </a:solidFill>
+                <a:latin typeface="Calibri"/>
+              </a:rPr>
+              <a:t>bill_length_mm</a:t>
+            </a:r>
+            <a:r>
+              <a:rPr lang="en-US" sz="1600" dirty="0">
+                <a:solidFill>
+                  <a:srgbClr val="222222"/>
+                </a:solidFill>
+                <a:latin typeface="Calibri"/>
+              </a:rPr>
+              <a:t> (largo del </a:t>
+            </a:r>
+            <a:r>
+              <a:rPr lang="en-US" sz="1600" dirty="0" err="1">
+                <a:solidFill>
+                  <a:srgbClr val="222222"/>
+                </a:solidFill>
+                <a:latin typeface="Calibri"/>
+              </a:rPr>
+              <a:t>pico</a:t>
+            </a:r>
+            <a:r>
+              <a:rPr lang="en-US" sz="1600" dirty="0">
+                <a:solidFill>
+                  <a:srgbClr val="222222"/>
+                </a:solidFill>
+                <a:latin typeface="Calibri"/>
+              </a:rPr>
+              <a:t>)</a:t>
+            </a:r>
+            <a:endParaRPr sz="1600" dirty="0">
+              <a:solidFill>
+                <a:srgbClr val="222222"/>
+              </a:solidFill>
+              <a:latin typeface="Calibri"/>
+            </a:endParaRPr>
           </a:p>
           <a:p>
             <a:pPr algn="l">
@@ -3896,14 +4724,74 @@
               </a:spcAft>
             </a:pPr>
             <a:r>
-              <a:rPr sz="1600">
-                <a:solidFill>
-                  <a:srgbClr val="222222"/>
-                </a:solidFill>
-                <a:latin typeface="Calibri"/>
-              </a:rPr>
-              <a:t>• bill_depth_mm</a:t>
-            </a:r>
+              <a:rPr sz="1600" dirty="0">
+                <a:solidFill>
+                  <a:srgbClr val="222222"/>
+                </a:solidFill>
+                <a:latin typeface="Calibri"/>
+              </a:rPr>
+              <a:t>• </a:t>
+            </a:r>
+            <a:r>
+              <a:rPr sz="1600" dirty="0" err="1">
+                <a:solidFill>
+                  <a:srgbClr val="222222"/>
+                </a:solidFill>
+                <a:latin typeface="Calibri"/>
+              </a:rPr>
+              <a:t>bill_depth_mm</a:t>
+            </a:r>
+            <a:r>
+              <a:rPr lang="en-US" sz="1600" dirty="0">
+                <a:solidFill>
+                  <a:srgbClr val="222222"/>
+                </a:solidFill>
+                <a:latin typeface="Calibri"/>
+              </a:rPr>
+              <a:t> (</a:t>
+            </a:r>
+            <a:r>
+              <a:rPr lang="en-US" sz="1600" dirty="0" err="1">
+                <a:solidFill>
+                  <a:srgbClr val="222222"/>
+                </a:solidFill>
+                <a:latin typeface="Calibri"/>
+              </a:rPr>
+              <a:t>profundidad</a:t>
+            </a:r>
+            <a:r>
+              <a:rPr lang="en-US" sz="1600" dirty="0">
+                <a:solidFill>
+                  <a:srgbClr val="222222"/>
+                </a:solidFill>
+                <a:latin typeface="Calibri"/>
+              </a:rPr>
+              <a:t> del </a:t>
+            </a:r>
+            <a:r>
+              <a:rPr lang="en-US" sz="1600" dirty="0" err="1">
+                <a:solidFill>
+                  <a:srgbClr val="222222"/>
+                </a:solidFill>
+                <a:latin typeface="Calibri"/>
+              </a:rPr>
+              <a:t>pico</a:t>
+            </a:r>
+            <a:r>
+              <a:rPr lang="en-US" sz="1600" dirty="0">
+                <a:solidFill>
+                  <a:srgbClr val="222222"/>
+                </a:solidFill>
+                <a:latin typeface="Calibri"/>
+              </a:rPr>
+              <a:t>)</a:t>
+            </a:r>
+            <a:endParaRPr sz="1600" dirty="0">
+              <a:solidFill>
+                <a:srgbClr val="222222"/>
+              </a:solidFill>
+              <a:latin typeface="Calibri"/>
+            </a:endParaRPr>
           </a:p>
           <a:p>
             <a:pPr algn="l">
@@ -3912,14 +4800,74 @@
               </a:spcAft>
             </a:pPr>
             <a:r>
-              <a:rPr sz="1600">
-                <a:solidFill>
-                  <a:srgbClr val="222222"/>
-                </a:solidFill>
-                <a:latin typeface="Calibri"/>
-              </a:rPr>
-              <a:t>• flipper_length_mm</a:t>
-            </a:r>
+              <a:rPr sz="1600" dirty="0">
+                <a:solidFill>
+                  <a:srgbClr val="222222"/>
+                </a:solidFill>
+                <a:latin typeface="Calibri"/>
+              </a:rPr>
+              <a:t>• </a:t>
+            </a:r>
+            <a:r>
+              <a:rPr sz="1600" dirty="0" err="1">
+                <a:solidFill>
+                  <a:srgbClr val="222222"/>
+                </a:solidFill>
+                <a:latin typeface="Calibri"/>
+              </a:rPr>
+              <a:t>flipper_length_mm</a:t>
+            </a:r>
+            <a:r>
+              <a:rPr lang="en-US" sz="1600" dirty="0">
+                <a:solidFill>
+                  <a:srgbClr val="222222"/>
+                </a:solidFill>
+                <a:latin typeface="Calibri"/>
+              </a:rPr>
+              <a:t> (</a:t>
+            </a:r>
+            <a:r>
+              <a:rPr lang="en-US" sz="1600" dirty="0" err="1">
+                <a:solidFill>
+                  <a:srgbClr val="222222"/>
+                </a:solidFill>
+                <a:latin typeface="Calibri"/>
+              </a:rPr>
+              <a:t>alrgo</a:t>
+            </a:r>
+            <a:r>
+              <a:rPr lang="en-US" sz="1600" dirty="0">
+                <a:solidFill>
+                  <a:srgbClr val="222222"/>
+                </a:solidFill>
+                <a:latin typeface="Calibri"/>
+              </a:rPr>
+              <a:t> de la </a:t>
+            </a:r>
+            <a:r>
+              <a:rPr lang="en-US" sz="1600" dirty="0" err="1">
+                <a:solidFill>
+                  <a:srgbClr val="222222"/>
+                </a:solidFill>
+                <a:latin typeface="Calibri"/>
+              </a:rPr>
+              <a:t>aleta</a:t>
+            </a:r>
+            <a:r>
+              <a:rPr lang="en-US" sz="1600" dirty="0">
+                <a:solidFill>
+                  <a:srgbClr val="222222"/>
+                </a:solidFill>
+                <a:latin typeface="Calibri"/>
+              </a:rPr>
+              <a:t>)</a:t>
+            </a:r>
+            <a:endParaRPr sz="1600" dirty="0">
+              <a:solidFill>
+                <a:srgbClr val="222222"/>
+              </a:solidFill>
+              <a:latin typeface="Calibri"/>
+            </a:endParaRPr>
           </a:p>
           <a:p>
             <a:pPr algn="l">
@@ -3928,14 +4876,38 @@
               </a:spcAft>
             </a:pPr>
             <a:r>
-              <a:rPr sz="1600">
-                <a:solidFill>
-                  <a:srgbClr val="222222"/>
-                </a:solidFill>
-                <a:latin typeface="Calibri"/>
-              </a:rPr>
-              <a:t>• body_mass_g</a:t>
-            </a:r>
+              <a:rPr sz="1600" dirty="0">
+                <a:solidFill>
+                  <a:srgbClr val="222222"/>
+                </a:solidFill>
+                <a:latin typeface="Calibri"/>
+              </a:rPr>
+              <a:t>• </a:t>
+            </a:r>
+            <a:r>
+              <a:rPr sz="1600" dirty="0" err="1">
+                <a:solidFill>
+                  <a:srgbClr val="222222"/>
+                </a:solidFill>
+                <a:latin typeface="Calibri"/>
+              </a:rPr>
+              <a:t>body_mass_g</a:t>
+            </a:r>
+            <a:r>
+              <a:rPr lang="en-US" sz="1600" dirty="0">
+                <a:solidFill>
+                  <a:srgbClr val="222222"/>
+                </a:solidFill>
+                <a:latin typeface="Calibri"/>
+              </a:rPr>
+              <a:t> (peso corporal)</a:t>
+            </a:r>
+            <a:endParaRPr sz="1600" dirty="0">
+              <a:solidFill>
+                <a:srgbClr val="222222"/>
+              </a:solidFill>
+              <a:latin typeface="Calibri"/>
+            </a:endParaRPr>
           </a:p>
         </p:txBody>
       </p:sp>
@@ -3972,7 +4944,7 @@
 </file>
 
 <file path=ppt/slides/slide4.xml><?xml version="1.0" encoding="utf-8"?>
-<p:sld xmlns:a="http://schemas.openxmlformats.org/drawingml/2006/main" xmlns:p="http://schemas.openxmlformats.org/presentationml/2006/main" xmlns:r="http://schemas.openxmlformats.org/officeDocument/2006/relationships">
+<p:sld xmlns:a="http://schemas.openxmlformats.org/drawingml/2006/main" xmlns:r="http://schemas.openxmlformats.org/officeDocument/2006/relationships" xmlns:p="http://schemas.openxmlformats.org/presentationml/2006/main">
   <p:cSld>
     <p:spTree>
       <p:nvGrpSpPr>
@@ -3980,7 +4952,14 @@
         <p:cNvGrpSpPr/>
         <p:nvPr/>
       </p:nvGrpSpPr>
-      <p:grpSpPr/>
+      <p:grpSpPr>
+        <a:xfrm>
+          <a:off x="0" y="0"/>
+          <a:ext cx="0" cy="0"/>
+          <a:chOff x="0" y="0"/>
+          <a:chExt cx="0" cy="0"/>
+        </a:xfrm>
+      </p:grpSpPr>
       <p:sp>
         <p:nvSpPr>
           <p:cNvPr id="2" name="Rectangle 1"/>
@@ -4021,6 +5000,7 @@
           <a:lstStyle/>
           <a:p>
             <a:pPr algn="ctr"/>
+            <a:endParaRPr/>
           </a:p>
         </p:txBody>
       </p:sp>
@@ -4136,6 +5116,7 @@
           <a:lstStyle/>
           <a:p>
             <a:pPr algn="ctr"/>
+            <a:endParaRPr/>
           </a:p>
         </p:txBody>
       </p:sp>
@@ -4287,6 +5268,7 @@
           <a:lstStyle/>
           <a:p>
             <a:pPr algn="ctr"/>
+            <a:endParaRPr/>
           </a:p>
         </p:txBody>
       </p:sp>
@@ -4438,6 +5420,7 @@
           <a:lstStyle/>
           <a:p>
             <a:pPr algn="ctr"/>
+            <a:endParaRPr/>
           </a:p>
         </p:txBody>
       </p:sp>
@@ -4556,7 +5539,7 @@
 </file>
 
 <file path=ppt/slides/slide5.xml><?xml version="1.0" encoding="utf-8"?>
-<p:sld xmlns:a="http://schemas.openxmlformats.org/drawingml/2006/main" xmlns:p="http://schemas.openxmlformats.org/presentationml/2006/main" xmlns:r="http://schemas.openxmlformats.org/officeDocument/2006/relationships">
+<p:sld xmlns:a="http://schemas.openxmlformats.org/drawingml/2006/main" xmlns:r="http://schemas.openxmlformats.org/officeDocument/2006/relationships" xmlns:p="http://schemas.openxmlformats.org/presentationml/2006/main">
   <p:cSld>
     <p:spTree>
       <p:nvGrpSpPr>
@@ -4564,7 +5547,14 @@
         <p:cNvGrpSpPr/>
         <p:nvPr/>
       </p:nvGrpSpPr>
-      <p:grpSpPr/>
+      <p:grpSpPr>
+        <a:xfrm>
+          <a:off x="0" y="0"/>
+          <a:ext cx="0" cy="0"/>
+          <a:chOff x="0" y="0"/>
+          <a:chExt cx="0" cy="0"/>
+        </a:xfrm>
+      </p:grpSpPr>
       <p:sp>
         <p:nvSpPr>
           <p:cNvPr id="2" name="Rectangle 1"/>
@@ -4605,6 +5595,7 @@
           <a:lstStyle/>
           <a:p>
             <a:pPr algn="ctr"/>
+            <a:endParaRPr/>
           </a:p>
         </p:txBody>
       </p:sp>
@@ -4697,10 +5688,34 @@
                 <a:tableStyleId>{5C22544A-7EE6-4342-B048-85BDC9FD1C3A}</a:tableStyleId>
               </a:tblPr>
               <a:tblGrid>
-                <a:gridCol w="1234440"/>
-                <a:gridCol w="1234440"/>
-                <a:gridCol w="1234440"/>
-                <a:gridCol w="1234440"/>
+                <a:gridCol w="1234440">
+                  <a:extLst>
+                    <a:ext uri="{9D8B030D-6E8A-4147-A177-3AD203B41FA5}">
+                      <a16:colId xmlns:a16="http://schemas.microsoft.com/office/drawing/2014/main" val="20000"/>
+                    </a:ext>
+                  </a:extLst>
+                </a:gridCol>
+                <a:gridCol w="1234440">
+                  <a:extLst>
+                    <a:ext uri="{9D8B030D-6E8A-4147-A177-3AD203B41FA5}">
+                      <a16:colId xmlns:a16="http://schemas.microsoft.com/office/drawing/2014/main" val="20001"/>
+                    </a:ext>
+                  </a:extLst>
+                </a:gridCol>
+                <a:gridCol w="1234440">
+                  <a:extLst>
+                    <a:ext uri="{9D8B030D-6E8A-4147-A177-3AD203B41FA5}">
+                      <a16:colId xmlns:a16="http://schemas.microsoft.com/office/drawing/2014/main" val="20002"/>
+                    </a:ext>
+                  </a:extLst>
+                </a:gridCol>
+                <a:gridCol w="1234440">
+                  <a:extLst>
+                    <a:ext uri="{9D8B030D-6E8A-4147-A177-3AD203B41FA5}">
+                      <a16:colId xmlns:a16="http://schemas.microsoft.com/office/drawing/2014/main" val="20003"/>
+                    </a:ext>
+                  </a:extLst>
+                </a:gridCol>
               </a:tblGrid>
               <a:tr h="525780">
                 <a:tc>
@@ -4795,6 +5810,11 @@
                     </a:solidFill>
                   </a:tcPr>
                 </a:tc>
+                <a:extLst>
+                  <a:ext uri="{0D108BD9-81ED-4DB2-BD59-A6C34878D82A}">
+                    <a16:rowId xmlns:a16="http://schemas.microsoft.com/office/drawing/2014/main" val="10000"/>
+                  </a:ext>
+                </a:extLst>
               </a:tr>
               <a:tr h="525780">
                 <a:tc>
@@ -4889,6 +5909,11 @@
                     </a:solidFill>
                   </a:tcPr>
                 </a:tc>
+                <a:extLst>
+                  <a:ext uri="{0D108BD9-81ED-4DB2-BD59-A6C34878D82A}">
+                    <a16:rowId xmlns:a16="http://schemas.microsoft.com/office/drawing/2014/main" val="10001"/>
+                  </a:ext>
+                </a:extLst>
               </a:tr>
               <a:tr h="525780">
                 <a:tc>
@@ -4983,6 +6008,11 @@
                     </a:solidFill>
                   </a:tcPr>
                 </a:tc>
+                <a:extLst>
+                  <a:ext uri="{0D108BD9-81ED-4DB2-BD59-A6C34878D82A}">
+                    <a16:rowId xmlns:a16="http://schemas.microsoft.com/office/drawing/2014/main" val="10002"/>
+                  </a:ext>
+                </a:extLst>
               </a:tr>
               <a:tr h="525780">
                 <a:tc>
@@ -4992,7 +6022,7 @@
                     <a:p>
                       <a:pPr algn="ctr"/>
                       <a:r>
-                        <a:rPr sz="1400">
+                        <a:rPr sz="1400" dirty="0">
                           <a:solidFill>
                             <a:srgbClr val="222222"/>
                           </a:solidFill>
@@ -5061,7 +6091,7 @@
                     <a:p>
                       <a:pPr algn="ctr"/>
                       <a:r>
-                        <a:rPr sz="1400">
+                        <a:rPr sz="1400" dirty="0">
                           <a:solidFill>
                             <a:srgbClr val="222222"/>
                           </a:solidFill>
@@ -5077,6 +6107,11 @@
                     </a:solidFill>
                   </a:tcPr>
                 </a:tc>
+                <a:extLst>
+                  <a:ext uri="{0D108BD9-81ED-4DB2-BD59-A6C34878D82A}">
+                    <a16:rowId xmlns:a16="http://schemas.microsoft.com/office/drawing/2014/main" val="10003"/>
+                  </a:ext>
+                </a:extLst>
               </a:tr>
             </a:tbl>
           </a:graphicData>
@@ -5145,13 +6180,67 @@
               </a:spcAft>
             </a:pPr>
             <a:r>
-              <a:rPr sz="1500">
-                <a:solidFill>
-                  <a:srgbClr val="222222"/>
-                </a:solidFill>
-                <a:latin typeface="Calibri"/>
-              </a:rPr>
-              <a:t>• Agglomerative recupera mejor las 3 especies (ARI = 0.92).</a:t>
+              <a:rPr sz="1500" dirty="0">
+                <a:solidFill>
+                  <a:srgbClr val="222222"/>
+                </a:solidFill>
+                <a:latin typeface="Calibri"/>
+              </a:rPr>
+              <a:t>• Agglomerative </a:t>
+            </a:r>
+            <a:r>
+              <a:rPr sz="1500" dirty="0" err="1">
+                <a:solidFill>
+                  <a:srgbClr val="222222"/>
+                </a:solidFill>
+                <a:latin typeface="Calibri"/>
+              </a:rPr>
+              <a:t>recupera</a:t>
+            </a:r>
+            <a:r>
+              <a:rPr sz="1500" dirty="0">
+                <a:solidFill>
+                  <a:srgbClr val="222222"/>
+                </a:solidFill>
+                <a:latin typeface="Calibri"/>
+              </a:rPr>
+              <a:t> </a:t>
+            </a:r>
+            <a:r>
+              <a:rPr sz="1500" dirty="0" err="1">
+                <a:solidFill>
+                  <a:srgbClr val="222222"/>
+                </a:solidFill>
+                <a:latin typeface="Calibri"/>
+              </a:rPr>
+              <a:t>mejor</a:t>
+            </a:r>
+            <a:r>
+              <a:rPr sz="1500" dirty="0">
+                <a:solidFill>
+                  <a:srgbClr val="222222"/>
+                </a:solidFill>
+                <a:latin typeface="Calibri"/>
+              </a:rPr>
+              <a:t> las 3 </a:t>
+            </a:r>
+            <a:r>
+              <a:rPr sz="1500" dirty="0" err="1">
+                <a:solidFill>
+                  <a:srgbClr val="222222"/>
+                </a:solidFill>
+                <a:latin typeface="Calibri"/>
+              </a:rPr>
+              <a:t>especies</a:t>
+            </a:r>
+            <a:r>
+              <a:rPr sz="1500" dirty="0">
+                <a:solidFill>
+                  <a:srgbClr val="222222"/>
+                </a:solidFill>
+                <a:latin typeface="Calibri"/>
+              </a:rPr>
+              <a:t> (ARI = 0.92).</a:t>
             </a:r>
           </a:p>
           <a:p>
@@ -5161,13 +6250,103 @@
               </a:spcAft>
             </a:pPr>
             <a:r>
-              <a:rPr sz="1500">
-                <a:solidFill>
-                  <a:srgbClr val="222222"/>
-                </a:solidFill>
-                <a:latin typeface="Calibri"/>
-              </a:rPr>
-              <a:t>• Tras mapear cluster → especie por mayoría: exactitud 96.8 % (331/342).</a:t>
+              <a:rPr sz="1500" dirty="0">
+                <a:solidFill>
+                  <a:srgbClr val="222222"/>
+                </a:solidFill>
+                <a:latin typeface="Calibri"/>
+              </a:rPr>
+              <a:t>• Tras </a:t>
+            </a:r>
+            <a:r>
+              <a:rPr sz="1500" dirty="0" err="1">
+                <a:solidFill>
+                  <a:srgbClr val="222222"/>
+                </a:solidFill>
+                <a:latin typeface="Calibri"/>
+              </a:rPr>
+              <a:t>mapear</a:t>
+            </a:r>
+            <a:r>
+              <a:rPr sz="1500" dirty="0">
+                <a:solidFill>
+                  <a:srgbClr val="222222"/>
+                </a:solidFill>
+                <a:latin typeface="Calibri"/>
+              </a:rPr>
+              <a:t> cluster → </a:t>
+            </a:r>
+            <a:r>
+              <a:rPr sz="1500" dirty="0" err="1">
+                <a:solidFill>
+                  <a:srgbClr val="222222"/>
+                </a:solidFill>
+                <a:latin typeface="Calibri"/>
+              </a:rPr>
+              <a:t>especie</a:t>
+            </a:r>
+            <a:r>
+              <a:rPr sz="1500" dirty="0">
+                <a:solidFill>
+                  <a:srgbClr val="222222"/>
+                </a:solidFill>
+                <a:latin typeface="Calibri"/>
+              </a:rPr>
+              <a:t> </a:t>
+            </a:r>
+            <a:r>
+              <a:rPr sz="1500" dirty="0" err="1">
+                <a:solidFill>
+                  <a:srgbClr val="222222"/>
+                </a:solidFill>
+                <a:latin typeface="Calibri"/>
+              </a:rPr>
+              <a:t>por</a:t>
+            </a:r>
+            <a:r>
+              <a:rPr sz="1500" dirty="0">
+                <a:solidFill>
+                  <a:srgbClr val="222222"/>
+                </a:solidFill>
+                <a:latin typeface="Calibri"/>
+              </a:rPr>
+              <a:t> </a:t>
+            </a:r>
+            <a:r>
+              <a:rPr sz="1500" dirty="0" err="1">
+                <a:solidFill>
+                  <a:srgbClr val="222222"/>
+                </a:solidFill>
+                <a:latin typeface="Calibri"/>
+              </a:rPr>
+              <a:t>mayoría</a:t>
+            </a:r>
+            <a:r>
+              <a:rPr sz="1500" dirty="0">
+                <a:solidFill>
+                  <a:srgbClr val="222222"/>
+                </a:solidFill>
+                <a:latin typeface="Calibri"/>
+              </a:rPr>
+              <a:t>: </a:t>
+            </a:r>
+            <a:r>
+              <a:rPr sz="1500" dirty="0" err="1">
+                <a:solidFill>
+                  <a:srgbClr val="222222"/>
+                </a:solidFill>
+                <a:latin typeface="Calibri"/>
+              </a:rPr>
+              <a:t>exactitud</a:t>
+            </a:r>
+            <a:r>
+              <a:rPr sz="1500" dirty="0">
+                <a:solidFill>
+                  <a:srgbClr val="222222"/>
+                </a:solidFill>
+                <a:latin typeface="Calibri"/>
+              </a:rPr>
+              <a:t> 96.8 % (331/342).</a:t>
             </a:r>
           </a:p>
           <a:p>
@@ -5177,13 +6356,31 @@
               </a:spcAft>
             </a:pPr>
             <a:r>
-              <a:rPr sz="1500">
-                <a:solidFill>
-                  <a:srgbClr val="222222"/>
-                </a:solidFill>
-                <a:latin typeface="Calibri"/>
-              </a:rPr>
-              <a:t>• Mapeo: Cluster 0 → Adelie, Cluster 1 → Gentoo, Cluster 2 → Chinstrap.</a:t>
+              <a:rPr sz="1500" dirty="0">
+                <a:solidFill>
+                  <a:srgbClr val="222222"/>
+                </a:solidFill>
+                <a:latin typeface="Calibri"/>
+              </a:rPr>
+              <a:t>• </a:t>
+            </a:r>
+            <a:r>
+              <a:rPr sz="1500" dirty="0" err="1">
+                <a:solidFill>
+                  <a:srgbClr val="222222"/>
+                </a:solidFill>
+                <a:latin typeface="Calibri"/>
+              </a:rPr>
+              <a:t>Mapeo</a:t>
+            </a:r>
+            <a:r>
+              <a:rPr sz="1500" dirty="0">
+                <a:solidFill>
+                  <a:srgbClr val="222222"/>
+                </a:solidFill>
+                <a:latin typeface="Calibri"/>
+              </a:rPr>
+              <a:t>: Cluster 0 → Adelie, Cluster 1 → Gentoo, Cluster 2 → Chinstrap.</a:t>
             </a:r>
           </a:p>
           <a:p>
@@ -5193,13 +6390,103 @@
               </a:spcAft>
             </a:pPr>
             <a:r>
-              <a:rPr sz="1500">
-                <a:solidFill>
-                  <a:srgbClr val="222222"/>
-                </a:solidFill>
-                <a:latin typeface="Calibri"/>
-              </a:rPr>
-              <a:t>• DBSCAN tiene mejor compacidad interna pero fusiona Adelie/Chinstrap.</a:t>
+              <a:rPr sz="1500" dirty="0">
+                <a:solidFill>
+                  <a:srgbClr val="222222"/>
+                </a:solidFill>
+                <a:latin typeface="Calibri"/>
+              </a:rPr>
+              <a:t>• DBSCAN </a:t>
+            </a:r>
+            <a:r>
+              <a:rPr sz="1500" dirty="0" err="1">
+                <a:solidFill>
+                  <a:srgbClr val="222222"/>
+                </a:solidFill>
+                <a:latin typeface="Calibri"/>
+              </a:rPr>
+              <a:t>tiene</a:t>
+            </a:r>
+            <a:r>
+              <a:rPr sz="1500" dirty="0">
+                <a:solidFill>
+                  <a:srgbClr val="222222"/>
+                </a:solidFill>
+                <a:latin typeface="Calibri"/>
+              </a:rPr>
+              <a:t> </a:t>
+            </a:r>
+            <a:r>
+              <a:rPr sz="1500" dirty="0" err="1">
+                <a:solidFill>
+                  <a:srgbClr val="222222"/>
+                </a:solidFill>
+                <a:latin typeface="Calibri"/>
+              </a:rPr>
+              <a:t>mejor</a:t>
+            </a:r>
+            <a:r>
+              <a:rPr sz="1500" dirty="0">
+                <a:solidFill>
+                  <a:srgbClr val="222222"/>
+                </a:solidFill>
+                <a:latin typeface="Calibri"/>
+              </a:rPr>
+              <a:t> </a:t>
+            </a:r>
+            <a:r>
+              <a:rPr sz="1500" dirty="0" err="1">
+                <a:solidFill>
+                  <a:srgbClr val="222222"/>
+                </a:solidFill>
+                <a:latin typeface="Calibri"/>
+              </a:rPr>
+              <a:t>compacidad</a:t>
+            </a:r>
+            <a:r>
+              <a:rPr sz="1500" dirty="0">
+                <a:solidFill>
+                  <a:srgbClr val="222222"/>
+                </a:solidFill>
+                <a:latin typeface="Calibri"/>
+              </a:rPr>
+              <a:t> interna </a:t>
+            </a:r>
+            <a:r>
+              <a:rPr sz="1500" dirty="0" err="1">
+                <a:solidFill>
+                  <a:srgbClr val="222222"/>
+                </a:solidFill>
+                <a:latin typeface="Calibri"/>
+              </a:rPr>
+              <a:t>pero</a:t>
+            </a:r>
+            <a:r>
+              <a:rPr sz="1500" dirty="0">
+                <a:solidFill>
+                  <a:srgbClr val="222222"/>
+                </a:solidFill>
+                <a:latin typeface="Calibri"/>
+              </a:rPr>
+              <a:t> </a:t>
+            </a:r>
+            <a:r>
+              <a:rPr sz="1500" dirty="0" err="1">
+                <a:solidFill>
+                  <a:srgbClr val="222222"/>
+                </a:solidFill>
+                <a:latin typeface="Calibri"/>
+              </a:rPr>
+              <a:t>fusiona</a:t>
+            </a:r>
+            <a:r>
+              <a:rPr sz="1500" dirty="0">
+                <a:solidFill>
+                  <a:srgbClr val="222222"/>
+                </a:solidFill>
+                <a:latin typeface="Calibri"/>
+              </a:rPr>
+              <a:t> Adelie/Chinstrap.</a:t>
             </a:r>
           </a:p>
           <a:p>
@@ -5209,13 +6496,103 @@
               </a:spcAft>
             </a:pPr>
             <a:r>
-              <a:rPr sz="1500">
-                <a:solidFill>
-                  <a:srgbClr val="222222"/>
-                </a:solidFill>
-                <a:latin typeface="Calibri"/>
-              </a:rPr>
-              <a:t>• K-Means es muy competitivo y mucho más rápido.</a:t>
+              <a:rPr sz="1500" dirty="0">
+                <a:solidFill>
+                  <a:srgbClr val="222222"/>
+                </a:solidFill>
+                <a:latin typeface="Calibri"/>
+              </a:rPr>
+              <a:t>• K-Means es </a:t>
+            </a:r>
+            <a:r>
+              <a:rPr sz="1500" dirty="0" err="1">
+                <a:solidFill>
+                  <a:srgbClr val="222222"/>
+                </a:solidFill>
+                <a:latin typeface="Calibri"/>
+              </a:rPr>
+              <a:t>muy</a:t>
+            </a:r>
+            <a:r>
+              <a:rPr sz="1500" dirty="0">
+                <a:solidFill>
+                  <a:srgbClr val="222222"/>
+                </a:solidFill>
+                <a:latin typeface="Calibri"/>
+              </a:rPr>
+              <a:t> </a:t>
+            </a:r>
+            <a:r>
+              <a:rPr sz="1500" dirty="0" err="1">
+                <a:solidFill>
+                  <a:srgbClr val="222222"/>
+                </a:solidFill>
+                <a:latin typeface="Calibri"/>
+              </a:rPr>
+              <a:t>competitivo</a:t>
+            </a:r>
+            <a:r>
+              <a:rPr sz="1500" dirty="0">
+                <a:solidFill>
+                  <a:srgbClr val="222222"/>
+                </a:solidFill>
+                <a:latin typeface="Calibri"/>
+              </a:rPr>
+              <a:t> y </a:t>
+            </a:r>
+            <a:r>
+              <a:rPr sz="1500" dirty="0" err="1">
+                <a:solidFill>
+                  <a:srgbClr val="222222"/>
+                </a:solidFill>
+                <a:latin typeface="Calibri"/>
+              </a:rPr>
+              <a:t>mucho</a:t>
+            </a:r>
+            <a:r>
+              <a:rPr sz="1500" dirty="0">
+                <a:solidFill>
+                  <a:srgbClr val="222222"/>
+                </a:solidFill>
+                <a:latin typeface="Calibri"/>
+              </a:rPr>
+              <a:t> </a:t>
+            </a:r>
+            <a:r>
+              <a:rPr sz="1500" dirty="0" err="1">
+                <a:solidFill>
+                  <a:srgbClr val="222222"/>
+                </a:solidFill>
+                <a:latin typeface="Calibri"/>
+              </a:rPr>
+              <a:t>más</a:t>
+            </a:r>
+            <a:r>
+              <a:rPr sz="1500" dirty="0">
+                <a:solidFill>
+                  <a:srgbClr val="222222"/>
+                </a:solidFill>
+                <a:latin typeface="Calibri"/>
+              </a:rPr>
+              <a:t> </a:t>
+            </a:r>
+            <a:r>
+              <a:rPr sz="1500" dirty="0" err="1">
+                <a:solidFill>
+                  <a:srgbClr val="222222"/>
+                </a:solidFill>
+                <a:latin typeface="Calibri"/>
+              </a:rPr>
+              <a:t>rápido</a:t>
+            </a:r>
+            <a:r>
+              <a:rPr sz="1500" dirty="0">
+                <a:solidFill>
+                  <a:srgbClr val="222222"/>
+                </a:solidFill>
+                <a:latin typeface="Calibri"/>
+              </a:rPr>
+              <a:t>.</a:t>
             </a:r>
           </a:p>
         </p:txBody>
@@ -5253,7 +6630,7 @@
 </file>
 
 <file path=ppt/slides/slide6.xml><?xml version="1.0" encoding="utf-8"?>
-<p:sld xmlns:a="http://schemas.openxmlformats.org/drawingml/2006/main" xmlns:p="http://schemas.openxmlformats.org/presentationml/2006/main" xmlns:r="http://schemas.openxmlformats.org/officeDocument/2006/relationships">
+<p:sld xmlns:a="http://schemas.openxmlformats.org/drawingml/2006/main" xmlns:r="http://schemas.openxmlformats.org/officeDocument/2006/relationships" xmlns:p="http://schemas.openxmlformats.org/presentationml/2006/main">
   <p:cSld>
     <p:spTree>
       <p:nvGrpSpPr>
@@ -5261,7 +6638,14 @@
         <p:cNvGrpSpPr/>
         <p:nvPr/>
       </p:nvGrpSpPr>
-      <p:grpSpPr/>
+      <p:grpSpPr>
+        <a:xfrm>
+          <a:off x="0" y="0"/>
+          <a:ext cx="0" cy="0"/>
+          <a:chOff x="0" y="0"/>
+          <a:chExt cx="0" cy="0"/>
+        </a:xfrm>
+      </p:grpSpPr>
       <p:sp>
         <p:nvSpPr>
           <p:cNvPr id="2" name="Rectangle 1"/>
@@ -5302,6 +6686,7 @@
           <a:lstStyle/>
           <a:p>
             <a:pPr algn="ctr"/>
+            <a:endParaRPr/>
           </a:p>
         </p:txBody>
       </p:sp>
@@ -5583,13 +6968,49 @@
               </a:spcAft>
             </a:pPr>
             <a:r>
-              <a:rPr sz="1600">
-                <a:solidFill>
-                  <a:srgbClr val="222222"/>
-                </a:solidFill>
-                <a:latin typeface="Calibri"/>
-              </a:rPr>
-              <a:t>• Incluir variables categóricas (sex, island) con encoding.</a:t>
+              <a:rPr sz="1600" dirty="0">
+                <a:solidFill>
+                  <a:srgbClr val="222222"/>
+                </a:solidFill>
+                <a:latin typeface="Calibri"/>
+              </a:rPr>
+              <a:t>• </a:t>
+            </a:r>
+            <a:r>
+              <a:rPr sz="1600" dirty="0" err="1">
+                <a:solidFill>
+                  <a:srgbClr val="222222"/>
+                </a:solidFill>
+                <a:latin typeface="Calibri"/>
+              </a:rPr>
+              <a:t>Incluir</a:t>
+            </a:r>
+            <a:r>
+              <a:rPr sz="1600" dirty="0">
+                <a:solidFill>
+                  <a:srgbClr val="222222"/>
+                </a:solidFill>
+                <a:latin typeface="Calibri"/>
+              </a:rPr>
+              <a:t> variables </a:t>
+            </a:r>
+            <a:r>
+              <a:rPr sz="1600" dirty="0" err="1">
+                <a:solidFill>
+                  <a:srgbClr val="222222"/>
+                </a:solidFill>
+                <a:latin typeface="Calibri"/>
+              </a:rPr>
+              <a:t>categóricas</a:t>
+            </a:r>
+            <a:r>
+              <a:rPr sz="1600" dirty="0">
+                <a:solidFill>
+                  <a:srgbClr val="222222"/>
+                </a:solidFill>
+                <a:latin typeface="Calibri"/>
+              </a:rPr>
+              <a:t> (sex, island) con encoding.</a:t>
             </a:r>
           </a:p>
           <a:p>
@@ -5599,13 +7020,67 @@
               </a:spcAft>
             </a:pPr>
             <a:r>
-              <a:rPr sz="1600">
-                <a:solidFill>
-                  <a:srgbClr val="222222"/>
-                </a:solidFill>
-                <a:latin typeface="Calibri"/>
-              </a:rPr>
-              <a:t>• Probar Gaussian Mixture Models y reducción de dimensionalidad con UMAP/t-SNE.</a:t>
+              <a:rPr sz="1600" dirty="0">
+                <a:solidFill>
+                  <a:srgbClr val="222222"/>
+                </a:solidFill>
+                <a:latin typeface="Calibri"/>
+              </a:rPr>
+              <a:t>• </a:t>
+            </a:r>
+            <a:r>
+              <a:rPr sz="1600" dirty="0" err="1">
+                <a:solidFill>
+                  <a:srgbClr val="222222"/>
+                </a:solidFill>
+                <a:latin typeface="Calibri"/>
+              </a:rPr>
+              <a:t>Probar</a:t>
+            </a:r>
+            <a:r>
+              <a:rPr sz="1600" dirty="0">
+                <a:solidFill>
+                  <a:srgbClr val="222222"/>
+                </a:solidFill>
+                <a:latin typeface="Calibri"/>
+              </a:rPr>
+              <a:t> Gaussian Mixture Models y </a:t>
+            </a:r>
+            <a:r>
+              <a:rPr sz="1600" dirty="0" err="1">
+                <a:solidFill>
+                  <a:srgbClr val="222222"/>
+                </a:solidFill>
+                <a:latin typeface="Calibri"/>
+              </a:rPr>
+              <a:t>reducción</a:t>
+            </a:r>
+            <a:r>
+              <a:rPr sz="1600" dirty="0">
+                <a:solidFill>
+                  <a:srgbClr val="222222"/>
+                </a:solidFill>
+                <a:latin typeface="Calibri"/>
+              </a:rPr>
+              <a:t> de </a:t>
+            </a:r>
+            <a:r>
+              <a:rPr sz="1600" dirty="0" err="1">
+                <a:solidFill>
+                  <a:srgbClr val="222222"/>
+                </a:solidFill>
+                <a:latin typeface="Calibri"/>
+              </a:rPr>
+              <a:t>dimensionalidad</a:t>
+            </a:r>
+            <a:r>
+              <a:rPr sz="1600" dirty="0">
+                <a:solidFill>
+                  <a:srgbClr val="222222"/>
+                </a:solidFill>
+                <a:latin typeface="Calibri"/>
+              </a:rPr>
+              <a:t> con UMAP/t-SNE.</a:t>
             </a:r>
           </a:p>
           <a:p>
@@ -5615,13 +7090,31 @@
               </a:spcAft>
             </a:pPr>
             <a:r>
-              <a:rPr sz="1600">
-                <a:solidFill>
-                  <a:srgbClr val="222222"/>
-                </a:solidFill>
-                <a:latin typeface="Calibri"/>
-              </a:rPr>
-              <a:t>• Validar estabilidad de clusters con bootstrap.</a:t>
+              <a:rPr sz="1600" dirty="0">
+                <a:solidFill>
+                  <a:srgbClr val="222222"/>
+                </a:solidFill>
+                <a:latin typeface="Calibri"/>
+              </a:rPr>
+              <a:t>• Validar </a:t>
+            </a:r>
+            <a:r>
+              <a:rPr sz="1600" dirty="0" err="1">
+                <a:solidFill>
+                  <a:srgbClr val="222222"/>
+                </a:solidFill>
+                <a:latin typeface="Calibri"/>
+              </a:rPr>
+              <a:t>estabilidad</a:t>
+            </a:r>
+            <a:r>
+              <a:rPr sz="1600" dirty="0">
+                <a:solidFill>
+                  <a:srgbClr val="222222"/>
+                </a:solidFill>
+                <a:latin typeface="Calibri"/>
+              </a:rPr>
+              <a:t> de clusters con bootstrap.</a:t>
             </a:r>
           </a:p>
         </p:txBody>

</xml_diff>